<commit_message>
Cập nhật hoàn thành back_end và front_end
</commit_message>
<xml_diff>
--- a/back_end/outputs/Global_Success_Book_4_Presentation.pptx
+++ b/back_end/outputs/Global_Success_Book_4_Presentation.pptx
@@ -75,11 +75,6 @@
     <p:sldId id="358" r:id="rId74"/>
     <p:sldId id="359" r:id="rId75"/>
     <p:sldId id="360" r:id="rId76"/>
-    <p:sldId id="361" r:id="rId77"/>
-    <p:sldId id="362" r:id="rId78"/>
-    <p:sldId id="363" r:id="rId79"/>
-    <p:sldId id="364" r:id="rId80"/>
-    <p:sldId id="365" r:id="rId81"/>
   </p:sldIdLst>
   <p:sldSz cx="12192000" cy="6858000"/>
   <p:notesSz cx="6858000" cy="9144000"/>
@@ -2876,7 +2871,7 @@
           <a:p>
             <a:pPr/>
             <a:r>
-              <a:t>What are your favorite leisure activities?</a:t>
+              <a:t>What do you like to do in your free time?</a:t>
             </a:r>
           </a:p>
         </p:txBody>
@@ -2915,7 +2910,7 @@
           <a:lstStyle/>
           <a:p>
             <a:r>
-              <a:t>Stage 1: Listen and Read</a:t>
+              <a:t>Listen and Read</a:t>
             </a:r>
           </a:p>
         </p:txBody>
@@ -2938,7 +2933,7 @@
           <a:p>
             <a:pPr/>
             <a:r>
-              <a:t>Listen to the conversation between Tom and Trang and follow along in your textbooks.</a:t>
+              <a:t>Listen to and read the conversation between Tom and Trang.</a:t>
             </a:r>
           </a:p>
         </p:txBody>
@@ -2977,7 +2972,7 @@
           <a:lstStyle/>
           <a:p>
             <a:r>
-              <a:t>Stage 2: Complete the Sentences</a:t>
+              <a:t>Complete the Sentences</a:t>
             </a:r>
           </a:p>
         </p:txBody>
@@ -3000,7 +2995,7 @@
           <a:p>
             <a:pPr/>
             <a:r>
-              <a:t>Read the conversation again and fill in the blanks in the sentences.</a:t>
+              <a:t>Complete sentences based on the dialogue.</a:t>
             </a:r>
           </a:p>
         </p:txBody>
@@ -3039,7 +3034,7 @@
           <a:lstStyle/>
           <a:p>
             <a:r>
-              <a:t>Stage 3: Work in Pairs</a:t>
+              <a:t>Categorize Activities</a:t>
             </a:r>
           </a:p>
         </p:txBody>
@@ -3062,7 +3057,7 @@
           <a:p>
             <a:pPr/>
             <a:r>
-              <a:t>Write activities under the correct pictures.</a:t>
+              <a:t>Write the activities from the box under the correct pictures.</a:t>
             </a:r>
           </a:p>
         </p:txBody>
@@ -3125,7 +3120,7 @@
           <a:lstStyle/>
           <a:p>
             <a:r>
-              <a:t>Stage 4: Guess the Activities</a:t>
+              <a:t>Match Descriptions to Activities</a:t>
             </a:r>
           </a:p>
         </p:txBody>
@@ -3148,7 +3143,7 @@
           <a:p>
             <a:pPr/>
             <a:r>
-              <a:t>Read phrases and guess which activities are described.</a:t>
+              <a:t>Read the phrases and guess which activities are described.</a:t>
             </a:r>
           </a:p>
         </p:txBody>
@@ -3187,7 +3182,7 @@
           <a:lstStyle/>
           <a:p>
             <a:r>
-              <a:t>Stage 5: Group Discussion</a:t>
+              <a:t>Group Discussion</a:t>
             </a:r>
           </a:p>
         </p:txBody>
@@ -3272,7 +3267,7 @@
           <a:p>
             <a:pPr/>
             <a:r>
-              <a:t>Summarize the lesson and address any questions.</a:t>
+              <a:t>Review key vocabulary and activities from the lesson.</a:t>
             </a:r>
           </a:p>
         </p:txBody>
@@ -3311,7 +3306,7 @@
           <a:lstStyle/>
           <a:p>
             <a:r>
-              <a:t>Unit 1 - Leisure Time</a:t>
+              <a:t>Unit 3: Hobbies</a:t>
             </a:r>
           </a:p>
         </p:txBody>
@@ -3837,7 +3832,13 @@
           <a:p>
             <a:pPr/>
             <a:r>
-              <a:t>What are your hobbies and interests?</a:t>
+              <a:t>Introduction to hobbies and interests</a:t>
+            </a:r>
+          </a:p>
+          <a:p>
+            <a:pPr/>
+            <a:r>
+              <a:t>What are your hobbies?</a:t>
             </a:r>
           </a:p>
         </p:txBody>
@@ -3876,7 +3877,7 @@
           <a:lstStyle/>
           <a:p>
             <a:r>
-              <a:t>Stage 1: Match Expressions</a:t>
+              <a:t>Stage 1: Vocabulary Matching</a:t>
             </a:r>
           </a:p>
         </p:txBody>
@@ -3899,7 +3900,7 @@
           <a:p>
             <a:pPr/>
             <a:r>
-              <a:t>Match words/phrases in column A with column B to create expressions about likes.</a:t>
+              <a:t>Match a word/phrase in column A with a word in column B to make expressions about likes.</a:t>
             </a:r>
           </a:p>
         </p:txBody>
@@ -3962,7 +3963,7 @@
           <a:lstStyle/>
           <a:p>
             <a:r>
-              <a:t>Stage 2: Fill in the Blanks</a:t>
+              <a:t>Stage 2: Vocabulary Fill-in-the-blanks</a:t>
             </a:r>
           </a:p>
         </p:txBody>
@@ -3985,7 +3986,7 @@
           <a:p>
             <a:pPr/>
             <a:r>
-              <a:t>Complete the sentences using the correct words from the box.</a:t>
+              <a:t>Fill in each blank with a correct word from the box.</a:t>
             </a:r>
           </a:p>
         </p:txBody>
@@ -4048,7 +4049,7 @@
           <a:lstStyle/>
           <a:p>
             <a:r>
-              <a:t>Stage 3: Complete Sentences</a:t>
+              <a:t>Stage 3: Sentence Completion</a:t>
             </a:r>
           </a:p>
         </p:txBody>
@@ -4071,7 +4072,7 @@
           <a:p>
             <a:pPr/>
             <a:r>
-              <a:t>Write sentences about your own likes and dislikes using the phrases provided.</a:t>
+              <a:t>Complete the sentences about what you like or dislike doing.</a:t>
             </a:r>
           </a:p>
         </p:txBody>
@@ -4157,7 +4158,7 @@
           <a:p>
             <a:pPr/>
             <a:r>
-              <a:t>Listen and repeat words, then categorize them into the correct columns based on their sounds.</a:t>
+              <a:t>Listen and repeat the words. Pay attention to the sounds /ʊ/ and /u:/.</a:t>
             </a:r>
           </a:p>
         </p:txBody>
@@ -4220,7 +4221,7 @@
           <a:lstStyle/>
           <a:p>
             <a:r>
-              <a:t>Stage 5: Listen and Practice Sentences</a:t>
+              <a:t>Stage 5: Sentence Practice</a:t>
             </a:r>
           </a:p>
         </p:txBody>
@@ -4243,7 +4244,7 @@
           <a:p>
             <a:pPr/>
             <a:r>
-              <a:t>Listen to sentences, underline words with /ʊ/, and circle words with /u:/. </a:t>
+              <a:t>Listen and practise the sentences. Underline the bold words with /ʊ/, and circle the bold words with /u:/.</a:t>
             </a:r>
           </a:p>
         </p:txBody>
@@ -4305,7 +4306,13 @@
           <a:p>
             <a:pPr/>
             <a:r>
-              <a:t>Summarize the lesson and address any questions.</a:t>
+              <a:t>Review of vocabulary and pronunciation covered in the lesson.</a:t>
+            </a:r>
+          </a:p>
+          <a:p>
+            <a:pPr/>
+            <a:r>
+              <a:t>What did you find interesting or challenging about the lesson?</a:t>
             </a:r>
           </a:p>
         </p:txBody>
@@ -4444,7 +4451,7 @@
           <a:p>
             <a:pPr/>
             <a:r>
-              <a:t>What are your favorite and least favorite activities?</a:t>
+              <a:t>What are some activities you like or dislike doing in your free time?</a:t>
             </a:r>
           </a:p>
         </p:txBody>
@@ -4483,7 +4490,7 @@
           <a:lstStyle/>
           <a:p>
             <a:r>
-              <a:t>Stage 1: Classify Verbs</a:t>
+              <a:t>Grammar Introduction</a:t>
             </a:r>
           </a:p>
         </p:txBody>
@@ -4506,7 +4513,13 @@
           <a:p>
             <a:pPr/>
             <a:r>
-              <a:t>Classify verbs into two categories: followed by gerunds only, and followed by both gerunds and to-infinitives.</a:t>
+              <a:t>Some verbs of liking and disliking can be followed by gerunds only. Example: They dislike surfing the net.</a:t>
+            </a:r>
+          </a:p>
+          <a:p>
+            <a:pPr/>
+            <a:r>
+              <a:t>Some are followed by both gerunds and to-infinitives. Example: I love going / to go to the cinema.</a:t>
             </a:r>
           </a:p>
         </p:txBody>
@@ -4528,7 +4541,7 @@
         <p:spPr>
           <a:xfrm>
             <a:off x="914400" y="1828800"/>
-            <a:ext cx="4114800" cy="3614606"/>
+            <a:ext cx="4114800" cy="2871886"/>
           </a:xfrm>
           <a:prstGeom prst="rect">
             <a:avLst/>
@@ -4967,7 +4980,7 @@
           <a:lstStyle/>
           <a:p>
             <a:r>
-              <a:t>Stage 2: Choose the Correct Answer</a:t>
+              <a:t>Unit 5: Leisure Activities</a:t>
             </a:r>
           </a:p>
         </p:txBody>
@@ -4979,6 +4992,27 @@
             <a:spLocks noGrp="1"/>
           </p:cNvSpPr>
           <p:nvPr>
+            <p:ph type="body" idx="10" sz="quarter"/>
+          </p:nvPr>
+        </p:nvSpPr>
+        <p:spPr/>
+        <p:txBody>
+          <a:bodyPr/>
+          <a:lstStyle/>
+          <a:p>
+            <a:r>
+              <a:t>COMMUNICATION</a:t>
+            </a:r>
+          </a:p>
+        </p:txBody>
+      </p:sp>
+      <p:sp>
+        <p:nvSpPr>
+          <p:cNvPr id="4" name="Text Placeholder 3"/>
+          <p:cNvSpPr>
+            <a:spLocks noGrp="1"/>
+          </p:cNvSpPr>
+          <p:nvPr>
             <p:ph type="body" idx="11" sz="quarter"/>
           </p:nvPr>
         </p:nvSpPr>
@@ -4987,12 +5021,6 @@
           <a:bodyPr/>
           <a:lstStyle/>
           <a:p/>
-          <a:p>
-            <a:pPr/>
-            <a:r>
-              <a:t>Choose the correct answer (A, B, or C) to complete sentences using verbs of liking and disliking.</a:t>
-            </a:r>
-          </a:p>
         </p:txBody>
       </p:sp>
     </p:spTree>
@@ -5029,7 +5057,7 @@
           <a:lstStyle/>
           <a:p>
             <a:r>
-              <a:t>Stage 3: Complete the Sentences</a:t>
+              <a:t>Warm-up</a:t>
             </a:r>
           </a:p>
         </p:txBody>
@@ -5052,35 +5080,17 @@
           <a:p>
             <a:pPr/>
             <a:r>
-              <a:t>Look at pictures and complete sentences using the verbs in brackets in their suitable form.</a:t>
-            </a:r>
-          </a:p>
-        </p:txBody>
-      </p:sp>
-      <p:pic>
-        <p:nvPicPr>
-          <p:cNvPr id="4" name="Picture 3" descr="image.jpg"/>
-          <p:cNvPicPr>
-            <a:picLocks noChangeAspect="1"/>
-          </p:cNvPicPr>
-          <p:nvPr/>
-        </p:nvPicPr>
-        <p:blipFill>
-          <a:blip r:embed="rId2"/>
-          <a:stretch>
-            <a:fillRect/>
-          </a:stretch>
-        </p:blipFill>
-        <p:spPr>
-          <a:xfrm>
-            <a:off x="914400" y="1828800"/>
-            <a:ext cx="4114800" cy="8912924"/>
-          </a:xfrm>
-          <a:prstGeom prst="rect">
-            <a:avLst/>
-          </a:prstGeom>
-        </p:spPr>
-      </p:pic>
+              <a:t>What are your favorite leisure activities?</a:t>
+            </a:r>
+          </a:p>
+          <a:p>
+            <a:pPr/>
+            <a:r>
+              <a:t>Have you ever invited someone to join you?</a:t>
+            </a:r>
+          </a:p>
+        </p:txBody>
+      </p:sp>
     </p:spTree>
   </p:cSld>
   <p:clrMapOvr>
@@ -5115,7 +5125,7 @@
           <a:lstStyle/>
           <a:p>
             <a:r>
-              <a:t>Stage 4: Complete Sentences About Yourself</a:t>
+              <a:t>Stage 1: Listen and Read</a:t>
             </a:r>
           </a:p>
         </p:txBody>
@@ -5138,356 +5148,13 @@
           <a:p>
             <a:pPr/>
             <a:r>
-              <a:t>Fill in blanks with your own preferences using verbs of liking and disliking.</a:t>
-            </a:r>
-          </a:p>
-        </p:txBody>
-      </p:sp>
-      <p:pic>
-        <p:nvPicPr>
-          <p:cNvPr id="4" name="Picture 3" descr="image.jpg"/>
-          <p:cNvPicPr>
-            <a:picLocks noChangeAspect="1"/>
-          </p:cNvPicPr>
-          <p:nvPr/>
-        </p:nvPicPr>
-        <p:blipFill>
-          <a:blip r:embed="rId2"/>
-          <a:stretch>
-            <a:fillRect/>
-          </a:stretch>
-        </p:blipFill>
-        <p:spPr>
-          <a:xfrm>
-            <a:off x="914400" y="1828800"/>
-            <a:ext cx="4114800" cy="2560320"/>
-          </a:xfrm>
-          <a:prstGeom prst="rect">
-            <a:avLst/>
-          </a:prstGeom>
-        </p:spPr>
-      </p:pic>
-    </p:spTree>
-  </p:cSld>
-  <p:clrMapOvr>
-    <a:masterClrMapping/>
-  </p:clrMapOvr>
-</p:sld>
-</file>
-
-<file path=ppt/slides/slide33.xml><?xml version="1.0" encoding="utf-8"?>
-<p:sld xmlns:a="http://schemas.openxmlformats.org/drawingml/2006/main" xmlns:p="http://schemas.openxmlformats.org/presentationml/2006/main" xmlns:r="http://schemas.openxmlformats.org/officeDocument/2006/relationships">
-  <p:cSld>
-    <p:spTree>
-      <p:nvGrpSpPr>
-        <p:cNvPr id="1" name=""/>
-        <p:cNvGrpSpPr/>
-        <p:nvPr/>
-      </p:nvGrpSpPr>
-      <p:grpSpPr/>
-      <p:sp>
-        <p:nvSpPr>
-          <p:cNvPr id="2" name="Title 1"/>
-          <p:cNvSpPr>
-            <a:spLocks noGrp="1"/>
-          </p:cNvSpPr>
-          <p:nvPr>
-            <p:ph type="title"/>
-          </p:nvPr>
-        </p:nvSpPr>
-        <p:spPr/>
-        <p:txBody>
-          <a:bodyPr/>
-          <a:lstStyle/>
-          <a:p>
-            <a:r>
-              <a:t>Stage 5: Game - Likes and Dislikes Mimes</a:t>
-            </a:r>
-          </a:p>
-        </p:txBody>
-      </p:sp>
-      <p:sp>
-        <p:nvSpPr>
-          <p:cNvPr id="3" name="Text Placeholder 2"/>
-          <p:cNvSpPr>
-            <a:spLocks noGrp="1"/>
-          </p:cNvSpPr>
-          <p:nvPr>
-            <p:ph type="body" idx="11" sz="quarter"/>
-          </p:nvPr>
-        </p:nvSpPr>
-        <p:spPr/>
-        <p:txBody>
-          <a:bodyPr/>
-          <a:lstStyle/>
-          <a:p/>
+              <a:t>Listen to the dialogues and follow along in your textbooks.</a:t>
+            </a:r>
+          </a:p>
           <a:p>
             <a:pPr/>
             <a:r>
-              <a:t>Play a game where you mime a leisure activity you like or dislike, and others guess the activity by asking Yes/No questions.</a:t>
-            </a:r>
-          </a:p>
-        </p:txBody>
-      </p:sp>
-    </p:spTree>
-  </p:cSld>
-  <p:clrMapOvr>
-    <a:masterClrMapping/>
-  </p:clrMapOvr>
-</p:sld>
-</file>
-
-<file path=ppt/slides/slide34.xml><?xml version="1.0" encoding="utf-8"?>
-<p:sld xmlns:a="http://schemas.openxmlformats.org/drawingml/2006/main" xmlns:p="http://schemas.openxmlformats.org/presentationml/2006/main" xmlns:r="http://schemas.openxmlformats.org/officeDocument/2006/relationships">
-  <p:cSld>
-    <p:spTree>
-      <p:nvGrpSpPr>
-        <p:cNvPr id="1" name=""/>
-        <p:cNvGrpSpPr/>
-        <p:nvPr/>
-      </p:nvGrpSpPr>
-      <p:grpSpPr/>
-      <p:sp>
-        <p:nvSpPr>
-          <p:cNvPr id="2" name="Title 1"/>
-          <p:cNvSpPr>
-            <a:spLocks noGrp="1"/>
-          </p:cNvSpPr>
-          <p:nvPr>
-            <p:ph type="title"/>
-          </p:nvPr>
-        </p:nvSpPr>
-        <p:spPr/>
-        <p:txBody>
-          <a:bodyPr/>
-          <a:lstStyle/>
-          <a:p>
-            <a:r>
-              <a:t>Wrap-up</a:t>
-            </a:r>
-          </a:p>
-        </p:txBody>
-      </p:sp>
-      <p:sp>
-        <p:nvSpPr>
-          <p:cNvPr id="3" name="Text Placeholder 2"/>
-          <p:cNvSpPr>
-            <a:spLocks noGrp="1"/>
-          </p:cNvSpPr>
-          <p:nvPr>
-            <p:ph type="body" idx="11" sz="quarter"/>
-          </p:nvPr>
-        </p:nvSpPr>
-        <p:spPr/>
-        <p:txBody>
-          <a:bodyPr/>
-          <a:lstStyle/>
-          <a:p/>
-          <a:p>
-            <a:pPr/>
-            <a:r>
-              <a:t>Summarize the lesson and address any questions.</a:t>
-            </a:r>
-          </a:p>
-        </p:txBody>
-      </p:sp>
-    </p:spTree>
-  </p:cSld>
-  <p:clrMapOvr>
-    <a:masterClrMapping/>
-  </p:clrMapOvr>
-</p:sld>
-</file>
-
-<file path=ppt/slides/slide35.xml><?xml version="1.0" encoding="utf-8"?>
-<p:sld xmlns:a="http://schemas.openxmlformats.org/drawingml/2006/main" xmlns:p="http://schemas.openxmlformats.org/presentationml/2006/main" xmlns:r="http://schemas.openxmlformats.org/officeDocument/2006/relationships">
-  <p:cSld>
-    <p:spTree>
-      <p:nvGrpSpPr>
-        <p:cNvPr id="1" name=""/>
-        <p:cNvGrpSpPr/>
-        <p:nvPr/>
-      </p:nvGrpSpPr>
-      <p:grpSpPr/>
-      <p:sp>
-        <p:nvSpPr>
-          <p:cNvPr id="2" name="Title 1"/>
-          <p:cNvSpPr>
-            <a:spLocks noGrp="1"/>
-          </p:cNvSpPr>
-          <p:nvPr>
-            <p:ph type="title"/>
-          </p:nvPr>
-        </p:nvSpPr>
-        <p:spPr/>
-        <p:txBody>
-          <a:bodyPr/>
-          <a:lstStyle/>
-          <a:p>
-            <a:r>
-              <a:t>Unit 1 - Leisure Time</a:t>
-            </a:r>
-          </a:p>
-        </p:txBody>
-      </p:sp>
-      <p:sp>
-        <p:nvSpPr>
-          <p:cNvPr id="3" name="Text Placeholder 2"/>
-          <p:cNvSpPr>
-            <a:spLocks noGrp="1"/>
-          </p:cNvSpPr>
-          <p:nvPr>
-            <p:ph type="body" idx="10" sz="quarter"/>
-          </p:nvPr>
-        </p:nvSpPr>
-        <p:spPr/>
-        <p:txBody>
-          <a:bodyPr/>
-          <a:lstStyle/>
-          <a:p>
-            <a:r>
-              <a:t>Communication</a:t>
-            </a:r>
-          </a:p>
-        </p:txBody>
-      </p:sp>
-      <p:sp>
-        <p:nvSpPr>
-          <p:cNvPr id="4" name="Text Placeholder 3"/>
-          <p:cNvSpPr>
-            <a:spLocks noGrp="1"/>
-          </p:cNvSpPr>
-          <p:nvPr>
-            <p:ph type="body" idx="11" sz="quarter"/>
-          </p:nvPr>
-        </p:nvSpPr>
-        <p:spPr/>
-        <p:txBody>
-          <a:bodyPr/>
-          <a:lstStyle/>
-          <a:p/>
-        </p:txBody>
-      </p:sp>
-    </p:spTree>
-  </p:cSld>
-  <p:clrMapOvr>
-    <a:masterClrMapping/>
-  </p:clrMapOvr>
-</p:sld>
-</file>
-
-<file path=ppt/slides/slide36.xml><?xml version="1.0" encoding="utf-8"?>
-<p:sld xmlns:a="http://schemas.openxmlformats.org/drawingml/2006/main" xmlns:p="http://schemas.openxmlformats.org/presentationml/2006/main" xmlns:r="http://schemas.openxmlformats.org/officeDocument/2006/relationships">
-  <p:cSld>
-    <p:spTree>
-      <p:nvGrpSpPr>
-        <p:cNvPr id="1" name=""/>
-        <p:cNvGrpSpPr/>
-        <p:nvPr/>
-      </p:nvGrpSpPr>
-      <p:grpSpPr/>
-      <p:sp>
-        <p:nvSpPr>
-          <p:cNvPr id="2" name="Title 1"/>
-          <p:cNvSpPr>
-            <a:spLocks noGrp="1"/>
-          </p:cNvSpPr>
-          <p:nvPr>
-            <p:ph type="title"/>
-          </p:nvPr>
-        </p:nvSpPr>
-        <p:spPr/>
-        <p:txBody>
-          <a:bodyPr/>
-          <a:lstStyle/>
-          <a:p>
-            <a:r>
-              <a:t>Warm-up</a:t>
-            </a:r>
-          </a:p>
-        </p:txBody>
-      </p:sp>
-      <p:sp>
-        <p:nvSpPr>
-          <p:cNvPr id="3" name="Text Placeholder 2"/>
-          <p:cNvSpPr>
-            <a:spLocks noGrp="1"/>
-          </p:cNvSpPr>
-          <p:nvPr>
-            <p:ph type="body" idx="11" sz="quarter"/>
-          </p:nvPr>
-        </p:nvSpPr>
-        <p:spPr/>
-        <p:txBody>
-          <a:bodyPr/>
-          <a:lstStyle/>
-          <a:p/>
-          <a:p>
-            <a:pPr/>
-            <a:r>
-              <a:t>How do you usually invite friends to join activities?</a:t>
-            </a:r>
-          </a:p>
-        </p:txBody>
-      </p:sp>
-    </p:spTree>
-  </p:cSld>
-  <p:clrMapOvr>
-    <a:masterClrMapping/>
-  </p:clrMapOvr>
-</p:sld>
-</file>
-
-<file path=ppt/slides/slide37.xml><?xml version="1.0" encoding="utf-8"?>
-<p:sld xmlns:a="http://schemas.openxmlformats.org/drawingml/2006/main" xmlns:p="http://schemas.openxmlformats.org/presentationml/2006/main" xmlns:r="http://schemas.openxmlformats.org/officeDocument/2006/relationships">
-  <p:cSld>
-    <p:spTree>
-      <p:nvGrpSpPr>
-        <p:cNvPr id="1" name=""/>
-        <p:cNvGrpSpPr/>
-        <p:nvPr/>
-      </p:nvGrpSpPr>
-      <p:grpSpPr/>
-      <p:sp>
-        <p:nvSpPr>
-          <p:cNvPr id="2" name="Title 1"/>
-          <p:cNvSpPr>
-            <a:spLocks noGrp="1"/>
-          </p:cNvSpPr>
-          <p:nvPr>
-            <p:ph type="title"/>
-          </p:nvPr>
-        </p:nvSpPr>
-        <p:spPr/>
-        <p:txBody>
-          <a:bodyPr/>
-          <a:lstStyle/>
-          <a:p>
-            <a:r>
-              <a:t>Stage 1: Listen and Read</a:t>
-            </a:r>
-          </a:p>
-        </p:txBody>
-      </p:sp>
-      <p:sp>
-        <p:nvSpPr>
-          <p:cNvPr id="3" name="Text Placeholder 2"/>
-          <p:cNvSpPr>
-            <a:spLocks noGrp="1"/>
-          </p:cNvSpPr>
-          <p:nvPr>
-            <p:ph type="body" idx="11" sz="quarter"/>
-          </p:nvPr>
-        </p:nvSpPr>
-        <p:spPr/>
-        <p:txBody>
-          <a:bodyPr/>
-          <a:lstStyle/>
-          <a:p/>
-          <a:p>
-            <a:pPr/>
-            <a:r>
-              <a:t>Listen to the dialogues and pay attention to the highlighted language.</a:t>
+              <a:t>Highlight the phrases used for inviting and accepting invitations: 'Would you like to go...?', 'I’d love to.', 'Do you fancy going...?', 'That’s great.'</a:t>
             </a:r>
           </a:p>
         </p:txBody>
@@ -5524,7 +5191,7 @@
 </p:sld>
 </file>
 
-<file path=ppt/slides/slide38.xml><?xml version="1.0" encoding="utf-8"?>
+<file path=ppt/slides/slide33.xml><?xml version="1.0" encoding="utf-8"?>
 <p:sld xmlns:a="http://schemas.openxmlformats.org/drawingml/2006/main" xmlns:p="http://schemas.openxmlformats.org/presentationml/2006/main" xmlns:r="http://schemas.openxmlformats.org/officeDocument/2006/relationships">
   <p:cSld>
     <p:spTree>
@@ -5550,7 +5217,7 @@
           <a:lstStyle/>
           <a:p>
             <a:r>
-              <a:t>Stage 2: Practice Inviting and Accepting Invitations</a:t>
+              <a:t>Stage 2: Practice in Pairs</a:t>
             </a:r>
           </a:p>
         </p:txBody>
@@ -5573,7 +5240,13 @@
           <a:p>
             <a:pPr/>
             <a:r>
-              <a:t>Practice inviting and accepting invitations in pairs.</a:t>
+              <a:t>Practice the dialogues with your partners, using the highlighted language from the dialogues.</a:t>
+            </a:r>
+          </a:p>
+          <a:p>
+            <a:pPr/>
+            <a:r>
+              <a:t>Scenarios: playing badminton, making paper flowers, trying home-made pizza.</a:t>
             </a:r>
           </a:p>
         </p:txBody>
@@ -5586,7 +5259,7 @@
 </p:sld>
 </file>
 
-<file path=ppt/slides/slide39.xml><?xml version="1.0" encoding="utf-8"?>
+<file path=ppt/slides/slide34.xml><?xml version="1.0" encoding="utf-8"?>
 <p:sld xmlns:a="http://schemas.openxmlformats.org/drawingml/2006/main" xmlns:p="http://schemas.openxmlformats.org/presentationml/2006/main" xmlns:r="http://schemas.openxmlformats.org/officeDocument/2006/relationships">
   <p:cSld>
     <p:spTree>
@@ -5612,7 +5285,7 @@
           <a:lstStyle/>
           <a:p>
             <a:r>
-              <a:t>Stage 3: Discuss Leisure Activities</a:t>
+              <a:t>Stage 3: Identify Activities</a:t>
             </a:r>
           </a:p>
         </p:txBody>
@@ -5635,7 +5308,7 @@
           <a:p>
             <a:pPr/>
             <a:r>
-              <a:t>Identify activities in images and discuss them.</a:t>
+              <a:t>Discuss in pairs what each activity is and share your answers with the class.</a:t>
             </a:r>
           </a:p>
         </p:txBody>
@@ -5672,165 +5345,7 @@
 </p:sld>
 </file>
 
-<file path=ppt/slides/slide4.xml><?xml version="1.0" encoding="utf-8"?>
-<p:sld xmlns:a="http://schemas.openxmlformats.org/drawingml/2006/main" xmlns:r="http://schemas.openxmlformats.org/officeDocument/2006/relationships" xmlns:p="http://schemas.openxmlformats.org/presentationml/2006/main">
-  <p:cSld>
-    <p:spTree>
-      <p:nvGrpSpPr>
-        <p:cNvPr id="1" name=""/>
-        <p:cNvGrpSpPr/>
-        <p:nvPr/>
-      </p:nvGrpSpPr>
-      <p:grpSpPr>
-        <a:xfrm>
-          <a:off x="0" y="0"/>
-          <a:ext cx="0" cy="0"/>
-          <a:chOff x="0" y="0"/>
-          <a:chExt cx="0" cy="0"/>
-        </a:xfrm>
-      </p:grpSpPr>
-      <p:sp>
-        <p:nvSpPr>
-          <p:cNvPr id="5" name="Title 4">
-            <a:extLst>
-              <a:ext uri="{FF2B5EF4-FFF2-40B4-BE49-F238E27FC236}">
-                <a16:creationId xmlns:a16="http://schemas.microsoft.com/office/drawing/2014/main" id="{534B320A-560D-4493-AA6A-79A2C8DC387F}"/>
-              </a:ext>
-            </a:extLst>
-          </p:cNvPr>
-          <p:cNvSpPr>
-            <a:spLocks noGrp="1"/>
-          </p:cNvSpPr>
-          <p:nvPr>
-            <p:ph type="title"/>
-          </p:nvPr>
-        </p:nvSpPr>
-        <p:spPr/>
-        <p:txBody>
-          <a:bodyPr/>
-          <a:lstStyle/>
-          <a:p>
-            <a:pPr algn="ctr"/>
-            <a:r>
-              <a:rPr lang="en-US" dirty="0"/>
-              <a:t>In-class Activity</a:t>
-            </a:r>
-          </a:p>
-        </p:txBody>
-      </p:sp>
-      <p:sp>
-        <p:nvSpPr>
-          <p:cNvPr id="3" name="Text Placeholder 2">
-            <a:extLst>
-              <a:ext uri="{FF2B5EF4-FFF2-40B4-BE49-F238E27FC236}">
-                <a16:creationId xmlns:a16="http://schemas.microsoft.com/office/drawing/2014/main" id="{E9A2FFE3-A7C7-9249-96D4-8D9AC15E0150}"/>
-              </a:ext>
-            </a:extLst>
-          </p:cNvPr>
-          <p:cNvSpPr>
-            <a:spLocks noGrp="1"/>
-          </p:cNvSpPr>
-          <p:nvPr>
-            <p:ph type="body" sz="quarter" idx="11"/>
-          </p:nvPr>
-        </p:nvSpPr>
-        <p:spPr/>
-        <p:txBody>
-          <a:bodyPr/>
-          <a:lstStyle/>
-          <a:p>
-            <a:pPr>
-              <a:lnSpc>
-                <a:spcPts val="2800"/>
-              </a:lnSpc>
-            </a:pPr>
-            <a:r>
-              <a:rPr lang="en-US" dirty="0"/>
-              <a:t>Invite parents to take part in an activity, and then discuss it. Some ideas include:</a:t>
-            </a:r>
-          </a:p>
-          <a:p>
-            <a:pPr marL="285750" indent="-285750">
-              <a:lnSpc>
-                <a:spcPts val="2800"/>
-              </a:lnSpc>
-              <a:buFont typeface="Arial" panose="020B0604020202020204" pitchFamily="34" charset="0"/>
-              <a:buChar char="•"/>
-            </a:pPr>
-            <a:r>
-              <a:rPr lang="en-US" dirty="0">
-                <a:solidFill>
-                  <a:schemeClr val="tx1">
-                    <a:lumMod val="75000"/>
-                    <a:lumOff val="25000"/>
-                  </a:schemeClr>
-                </a:solidFill>
-              </a:rPr>
-              <a:t>Solving a math problem, such as estimating the number of beans in a jar.</a:t>
-            </a:r>
-          </a:p>
-          <a:p>
-            <a:pPr marL="285750" indent="-285750">
-              <a:lnSpc>
-                <a:spcPts val="2800"/>
-              </a:lnSpc>
-              <a:buFont typeface="Arial" panose="020B0604020202020204" pitchFamily="34" charset="0"/>
-              <a:buChar char="•"/>
-            </a:pPr>
-            <a:r>
-              <a:rPr lang="en-US" dirty="0">
-                <a:solidFill>
-                  <a:schemeClr val="tx1">
-                    <a:lumMod val="75000"/>
-                    <a:lumOff val="25000"/>
-                  </a:schemeClr>
-                </a:solidFill>
-              </a:rPr>
-              <a:t>Writing an encouraging letter to their child. </a:t>
-            </a:r>
-          </a:p>
-          <a:p>
-            <a:pPr marL="285750" indent="-285750">
-              <a:lnSpc>
-                <a:spcPts val="2800"/>
-              </a:lnSpc>
-              <a:buFont typeface="Arial" panose="020B0604020202020204" pitchFamily="34" charset="0"/>
-              <a:buChar char="•"/>
-            </a:pPr>
-            <a:r>
-              <a:rPr lang="en-US" dirty="0">
-                <a:solidFill>
-                  <a:schemeClr val="tx1">
-                    <a:lumMod val="75000"/>
-                    <a:lumOff val="25000"/>
-                  </a:schemeClr>
-                </a:solidFill>
-              </a:rPr>
-              <a:t>Going on a classroom scavenger hunt for their child's work, the books their child likes best, and messages from their child. </a:t>
-            </a:r>
-          </a:p>
-          <a:p>
-            <a:endParaRPr lang="en-US" dirty="0"/>
-          </a:p>
-          <a:p>
-            <a:endParaRPr lang="en-US"/>
-          </a:p>
-        </p:txBody>
-      </p:sp>
-    </p:spTree>
-    <p:extLst>
-      <p:ext uri="{BB962C8B-B14F-4D97-AF65-F5344CB8AC3E}">
-        <p14:creationId xmlns:p14="http://schemas.microsoft.com/office/powerpoint/2010/main" val="524939592"/>
-      </p:ext>
-    </p:extLst>
-  </p:cSld>
-  <p:clrMapOvr>
-    <a:masterClrMapping/>
-  </p:clrMapOvr>
-</p:sld>
-</file>
-
-<file path=ppt/slides/slide40.xml><?xml version="1.0" encoding="utf-8"?>
+<file path=ppt/slides/slide35.xml><?xml version="1.0" encoding="utf-8"?>
 <p:sld xmlns:a="http://schemas.openxmlformats.org/drawingml/2006/main" xmlns:p="http://schemas.openxmlformats.org/presentationml/2006/main" xmlns:r="http://schemas.openxmlformats.org/officeDocument/2006/relationships">
   <p:cSld>
     <p:spTree>
@@ -5856,7 +5371,7 @@
           <a:lstStyle/>
           <a:p>
             <a:r>
-              <a:t>Stage 4: Complete a Table</a:t>
+              <a:t>Stage 4: Read and Complete Table</a:t>
             </a:r>
           </a:p>
         </p:txBody>
@@ -5879,7 +5394,13 @@
           <a:p>
             <a:pPr/>
             <a:r>
-              <a:t>Read texts about leisure activities and fill in a table with the information.</a:t>
+              <a:t>Read the text about Sakura, Eric, and Lan's leisure activities.</a:t>
+            </a:r>
+          </a:p>
+          <a:p>
+            <a:pPr/>
+            <a:r>
+              <a:t>Read the text and complete the table with information about each teenager's leisure activity, who they do it with, and the benefits.</a:t>
             </a:r>
           </a:p>
         </p:txBody>
@@ -5940,6 +5461,495 @@
 </p:sld>
 </file>
 
+<file path=ppt/slides/slide36.xml><?xml version="1.0" encoding="utf-8"?>
+<p:sld xmlns:a="http://schemas.openxmlformats.org/drawingml/2006/main" xmlns:p="http://schemas.openxmlformats.org/presentationml/2006/main" xmlns:r="http://schemas.openxmlformats.org/officeDocument/2006/relationships">
+  <p:cSld>
+    <p:spTree>
+      <p:nvGrpSpPr>
+        <p:cNvPr id="1" name=""/>
+        <p:cNvGrpSpPr/>
+        <p:nvPr/>
+      </p:nvGrpSpPr>
+      <p:grpSpPr/>
+      <p:sp>
+        <p:nvSpPr>
+          <p:cNvPr id="2" name="Title 1"/>
+          <p:cNvSpPr>
+            <a:spLocks noGrp="1"/>
+          </p:cNvSpPr>
+          <p:nvPr>
+            <p:ph type="title"/>
+          </p:nvPr>
+        </p:nvSpPr>
+        <p:spPr/>
+        <p:txBody>
+          <a:bodyPr/>
+          <a:lstStyle/>
+          <a:p>
+            <a:r>
+              <a:t>Stage 5: Group Discussion</a:t>
+            </a:r>
+          </a:p>
+        </p:txBody>
+      </p:sp>
+      <p:sp>
+        <p:nvSpPr>
+          <p:cNvPr id="3" name="Text Placeholder 2"/>
+          <p:cNvSpPr>
+            <a:spLocks noGrp="1"/>
+          </p:cNvSpPr>
+          <p:nvPr>
+            <p:ph type="body" idx="11" sz="quarter"/>
+          </p:nvPr>
+        </p:nvSpPr>
+        <p:spPr/>
+        <p:txBody>
+          <a:bodyPr/>
+          <a:lstStyle/>
+          <a:p/>
+          <a:p>
+            <a:pPr/>
+            <a:r>
+              <a:t>Which activity would you like to try? Why do you want to try it?</a:t>
+            </a:r>
+          </a:p>
+          <a:p>
+            <a:pPr/>
+            <a:r>
+              <a:t>Discuss in groups and prepare to report your answers.</a:t>
+            </a:r>
+          </a:p>
+        </p:txBody>
+      </p:sp>
+    </p:spTree>
+  </p:cSld>
+  <p:clrMapOvr>
+    <a:masterClrMapping/>
+  </p:clrMapOvr>
+</p:sld>
+</file>
+
+<file path=ppt/slides/slide37.xml><?xml version="1.0" encoding="utf-8"?>
+<p:sld xmlns:a="http://schemas.openxmlformats.org/drawingml/2006/main" xmlns:p="http://schemas.openxmlformats.org/presentationml/2006/main" xmlns:r="http://schemas.openxmlformats.org/officeDocument/2006/relationships">
+  <p:cSld>
+    <p:spTree>
+      <p:nvGrpSpPr>
+        <p:cNvPr id="1" name=""/>
+        <p:cNvGrpSpPr/>
+        <p:nvPr/>
+      </p:nvGrpSpPr>
+      <p:grpSpPr/>
+      <p:sp>
+        <p:nvSpPr>
+          <p:cNvPr id="2" name="Title 1"/>
+          <p:cNvSpPr>
+            <a:spLocks noGrp="1"/>
+          </p:cNvSpPr>
+          <p:nvPr>
+            <p:ph type="title"/>
+          </p:nvPr>
+        </p:nvSpPr>
+        <p:spPr/>
+        <p:txBody>
+          <a:bodyPr/>
+          <a:lstStyle/>
+          <a:p>
+            <a:r>
+              <a:t>Wrap-up</a:t>
+            </a:r>
+          </a:p>
+        </p:txBody>
+      </p:sp>
+      <p:sp>
+        <p:nvSpPr>
+          <p:cNvPr id="3" name="Text Placeholder 2"/>
+          <p:cNvSpPr>
+            <a:spLocks noGrp="1"/>
+          </p:cNvSpPr>
+          <p:nvPr>
+            <p:ph type="body" idx="11" sz="quarter"/>
+          </p:nvPr>
+        </p:nvSpPr>
+        <p:spPr/>
+        <p:txBody>
+          <a:bodyPr/>
+          <a:lstStyle/>
+          <a:p/>
+          <a:p>
+            <a:pPr/>
+            <a:r>
+              <a:t>What did you find most interesting about the lesson?</a:t>
+            </a:r>
+          </a:p>
+        </p:txBody>
+      </p:sp>
+    </p:spTree>
+  </p:cSld>
+  <p:clrMapOvr>
+    <a:masterClrMapping/>
+  </p:clrMapOvr>
+</p:sld>
+</file>
+
+<file path=ppt/slides/slide38.xml><?xml version="1.0" encoding="utf-8"?>
+<p:sld xmlns:a="http://schemas.openxmlformats.org/drawingml/2006/main" xmlns:p="http://schemas.openxmlformats.org/presentationml/2006/main" xmlns:r="http://schemas.openxmlformats.org/officeDocument/2006/relationships">
+  <p:cSld>
+    <p:spTree>
+      <p:nvGrpSpPr>
+        <p:cNvPr id="1" name=""/>
+        <p:cNvGrpSpPr/>
+        <p:nvPr/>
+      </p:nvGrpSpPr>
+      <p:grpSpPr/>
+      <p:sp>
+        <p:nvSpPr>
+          <p:cNvPr id="2" name="Title 1"/>
+          <p:cNvSpPr>
+            <a:spLocks noGrp="1"/>
+          </p:cNvSpPr>
+          <p:nvPr>
+            <p:ph type="title"/>
+          </p:nvPr>
+        </p:nvSpPr>
+        <p:spPr/>
+        <p:txBody>
+          <a:bodyPr/>
+          <a:lstStyle/>
+          <a:p>
+            <a:r>
+              <a:t>Leisure Activities</a:t>
+            </a:r>
+          </a:p>
+        </p:txBody>
+      </p:sp>
+      <p:sp>
+        <p:nvSpPr>
+          <p:cNvPr id="3" name="Text Placeholder 2"/>
+          <p:cNvSpPr>
+            <a:spLocks noGrp="1"/>
+          </p:cNvSpPr>
+          <p:nvPr>
+            <p:ph type="body" idx="10" sz="quarter"/>
+          </p:nvPr>
+        </p:nvSpPr>
+        <p:spPr/>
+        <p:txBody>
+          <a:bodyPr/>
+          <a:lstStyle/>
+          <a:p>
+            <a:r>
+              <a:t>Skills 1</a:t>
+            </a:r>
+          </a:p>
+        </p:txBody>
+      </p:sp>
+      <p:sp>
+        <p:nvSpPr>
+          <p:cNvPr id="4" name="Text Placeholder 3"/>
+          <p:cNvSpPr>
+            <a:spLocks noGrp="1"/>
+          </p:cNvSpPr>
+          <p:nvPr>
+            <p:ph type="body" idx="11" sz="quarter"/>
+          </p:nvPr>
+        </p:nvSpPr>
+        <p:spPr/>
+        <p:txBody>
+          <a:bodyPr/>
+          <a:lstStyle/>
+          <a:p/>
+        </p:txBody>
+      </p:sp>
+    </p:spTree>
+  </p:cSld>
+  <p:clrMapOvr>
+    <a:masterClrMapping/>
+  </p:clrMapOvr>
+</p:sld>
+</file>
+
+<file path=ppt/slides/slide39.xml><?xml version="1.0" encoding="utf-8"?>
+<p:sld xmlns:a="http://schemas.openxmlformats.org/drawingml/2006/main" xmlns:p="http://schemas.openxmlformats.org/presentationml/2006/main" xmlns:r="http://schemas.openxmlformats.org/officeDocument/2006/relationships">
+  <p:cSld>
+    <p:spTree>
+      <p:nvGrpSpPr>
+        <p:cNvPr id="1" name=""/>
+        <p:cNvGrpSpPr/>
+        <p:nvPr/>
+      </p:nvGrpSpPr>
+      <p:grpSpPr/>
+      <p:sp>
+        <p:nvSpPr>
+          <p:cNvPr id="2" name="Title 1"/>
+          <p:cNvSpPr>
+            <a:spLocks noGrp="1"/>
+          </p:cNvSpPr>
+          <p:nvPr>
+            <p:ph type="title"/>
+          </p:nvPr>
+        </p:nvSpPr>
+        <p:spPr/>
+        <p:txBody>
+          <a:bodyPr/>
+          <a:lstStyle/>
+          <a:p>
+            <a:r>
+              <a:t>Warm-up</a:t>
+            </a:r>
+          </a:p>
+        </p:txBody>
+      </p:sp>
+      <p:sp>
+        <p:nvSpPr>
+          <p:cNvPr id="3" name="Text Placeholder 2"/>
+          <p:cNvSpPr>
+            <a:spLocks noGrp="1"/>
+          </p:cNvSpPr>
+          <p:nvPr>
+            <p:ph type="body" idx="11" sz="quarter"/>
+          </p:nvPr>
+        </p:nvSpPr>
+        <p:spPr/>
+        <p:txBody>
+          <a:bodyPr/>
+          <a:lstStyle/>
+          <a:p/>
+          <a:p>
+            <a:pPr/>
+            <a:r>
+              <a:t>What are some leisure activities you know?</a:t>
+            </a:r>
+          </a:p>
+        </p:txBody>
+      </p:sp>
+    </p:spTree>
+  </p:cSld>
+  <p:clrMapOvr>
+    <a:masterClrMapping/>
+  </p:clrMapOvr>
+</p:sld>
+</file>
+
+<file path=ppt/slides/slide4.xml><?xml version="1.0" encoding="utf-8"?>
+<p:sld xmlns:a="http://schemas.openxmlformats.org/drawingml/2006/main" xmlns:r="http://schemas.openxmlformats.org/officeDocument/2006/relationships" xmlns:p="http://schemas.openxmlformats.org/presentationml/2006/main">
+  <p:cSld>
+    <p:spTree>
+      <p:nvGrpSpPr>
+        <p:cNvPr id="1" name=""/>
+        <p:cNvGrpSpPr/>
+        <p:nvPr/>
+      </p:nvGrpSpPr>
+      <p:grpSpPr>
+        <a:xfrm>
+          <a:off x="0" y="0"/>
+          <a:ext cx="0" cy="0"/>
+          <a:chOff x="0" y="0"/>
+          <a:chExt cx="0" cy="0"/>
+        </a:xfrm>
+      </p:grpSpPr>
+      <p:sp>
+        <p:nvSpPr>
+          <p:cNvPr id="5" name="Title 4">
+            <a:extLst>
+              <a:ext uri="{FF2B5EF4-FFF2-40B4-BE49-F238E27FC236}">
+                <a16:creationId xmlns:a16="http://schemas.microsoft.com/office/drawing/2014/main" id="{534B320A-560D-4493-AA6A-79A2C8DC387F}"/>
+              </a:ext>
+            </a:extLst>
+          </p:cNvPr>
+          <p:cNvSpPr>
+            <a:spLocks noGrp="1"/>
+          </p:cNvSpPr>
+          <p:nvPr>
+            <p:ph type="title"/>
+          </p:nvPr>
+        </p:nvSpPr>
+        <p:spPr/>
+        <p:txBody>
+          <a:bodyPr/>
+          <a:lstStyle/>
+          <a:p>
+            <a:pPr algn="ctr"/>
+            <a:r>
+              <a:rPr lang="en-US" dirty="0"/>
+              <a:t>In-class Activity</a:t>
+            </a:r>
+          </a:p>
+        </p:txBody>
+      </p:sp>
+      <p:sp>
+        <p:nvSpPr>
+          <p:cNvPr id="3" name="Text Placeholder 2">
+            <a:extLst>
+              <a:ext uri="{FF2B5EF4-FFF2-40B4-BE49-F238E27FC236}">
+                <a16:creationId xmlns:a16="http://schemas.microsoft.com/office/drawing/2014/main" id="{E9A2FFE3-A7C7-9249-96D4-8D9AC15E0150}"/>
+              </a:ext>
+            </a:extLst>
+          </p:cNvPr>
+          <p:cNvSpPr>
+            <a:spLocks noGrp="1"/>
+          </p:cNvSpPr>
+          <p:nvPr>
+            <p:ph type="body" sz="quarter" idx="11"/>
+          </p:nvPr>
+        </p:nvSpPr>
+        <p:spPr/>
+        <p:txBody>
+          <a:bodyPr/>
+          <a:lstStyle/>
+          <a:p>
+            <a:pPr>
+              <a:lnSpc>
+                <a:spcPts val="2800"/>
+              </a:lnSpc>
+            </a:pPr>
+            <a:r>
+              <a:rPr lang="en-US" dirty="0"/>
+              <a:t>Invite parents to take part in an activity, and then discuss it. Some ideas include:</a:t>
+            </a:r>
+          </a:p>
+          <a:p>
+            <a:pPr marL="285750" indent="-285750">
+              <a:lnSpc>
+                <a:spcPts val="2800"/>
+              </a:lnSpc>
+              <a:buFont typeface="Arial" panose="020B0604020202020204" pitchFamily="34" charset="0"/>
+              <a:buChar char="•"/>
+            </a:pPr>
+            <a:r>
+              <a:rPr lang="en-US" dirty="0">
+                <a:solidFill>
+                  <a:schemeClr val="tx1">
+                    <a:lumMod val="75000"/>
+                    <a:lumOff val="25000"/>
+                  </a:schemeClr>
+                </a:solidFill>
+              </a:rPr>
+              <a:t>Solving a math problem, such as estimating the number of beans in a jar.</a:t>
+            </a:r>
+          </a:p>
+          <a:p>
+            <a:pPr marL="285750" indent="-285750">
+              <a:lnSpc>
+                <a:spcPts val="2800"/>
+              </a:lnSpc>
+              <a:buFont typeface="Arial" panose="020B0604020202020204" pitchFamily="34" charset="0"/>
+              <a:buChar char="•"/>
+            </a:pPr>
+            <a:r>
+              <a:rPr lang="en-US" dirty="0">
+                <a:solidFill>
+                  <a:schemeClr val="tx1">
+                    <a:lumMod val="75000"/>
+                    <a:lumOff val="25000"/>
+                  </a:schemeClr>
+                </a:solidFill>
+              </a:rPr>
+              <a:t>Writing an encouraging letter to their child. </a:t>
+            </a:r>
+          </a:p>
+          <a:p>
+            <a:pPr marL="285750" indent="-285750">
+              <a:lnSpc>
+                <a:spcPts val="2800"/>
+              </a:lnSpc>
+              <a:buFont typeface="Arial" panose="020B0604020202020204" pitchFamily="34" charset="0"/>
+              <a:buChar char="•"/>
+            </a:pPr>
+            <a:r>
+              <a:rPr lang="en-US" dirty="0">
+                <a:solidFill>
+                  <a:schemeClr val="tx1">
+                    <a:lumMod val="75000"/>
+                    <a:lumOff val="25000"/>
+                  </a:schemeClr>
+                </a:solidFill>
+              </a:rPr>
+              <a:t>Going on a classroom scavenger hunt for their child's work, the books their child likes best, and messages from their child. </a:t>
+            </a:r>
+          </a:p>
+          <a:p>
+            <a:endParaRPr lang="en-US" dirty="0"/>
+          </a:p>
+          <a:p>
+            <a:endParaRPr lang="en-US"/>
+          </a:p>
+        </p:txBody>
+      </p:sp>
+    </p:spTree>
+    <p:extLst>
+      <p:ext uri="{BB962C8B-B14F-4D97-AF65-F5344CB8AC3E}">
+        <p14:creationId xmlns:p14="http://schemas.microsoft.com/office/powerpoint/2010/main" val="524939592"/>
+      </p:ext>
+    </p:extLst>
+  </p:cSld>
+  <p:clrMapOvr>
+    <a:masterClrMapping/>
+  </p:clrMapOvr>
+</p:sld>
+</file>
+
+<file path=ppt/slides/slide40.xml><?xml version="1.0" encoding="utf-8"?>
+<p:sld xmlns:a="http://schemas.openxmlformats.org/drawingml/2006/main" xmlns:p="http://schemas.openxmlformats.org/presentationml/2006/main" xmlns:r="http://schemas.openxmlformats.org/officeDocument/2006/relationships">
+  <p:cSld>
+    <p:spTree>
+      <p:nvGrpSpPr>
+        <p:cNvPr id="1" name=""/>
+        <p:cNvGrpSpPr/>
+        <p:nvPr/>
+      </p:nvGrpSpPr>
+      <p:grpSpPr/>
+      <p:sp>
+        <p:nvSpPr>
+          <p:cNvPr id="2" name="Title 1"/>
+          <p:cNvSpPr>
+            <a:spLocks noGrp="1"/>
+          </p:cNvSpPr>
+          <p:nvPr>
+            <p:ph type="title"/>
+          </p:nvPr>
+        </p:nvSpPr>
+        <p:spPr/>
+        <p:txBody>
+          <a:bodyPr/>
+          <a:lstStyle/>
+          <a:p>
+            <a:r>
+              <a:t>Task 1: Picture Discussion</a:t>
+            </a:r>
+          </a:p>
+        </p:txBody>
+      </p:sp>
+      <p:sp>
+        <p:nvSpPr>
+          <p:cNvPr id="3" name="Text Placeholder 2"/>
+          <p:cNvSpPr>
+            <a:spLocks noGrp="1"/>
+          </p:cNvSpPr>
+          <p:nvPr>
+            <p:ph type="body" idx="11" sz="quarter"/>
+          </p:nvPr>
+        </p:nvSpPr>
+        <p:spPr/>
+        <p:txBody>
+          <a:bodyPr/>
+          <a:lstStyle/>
+          <a:p/>
+          <a:p>
+            <a:pPr/>
+            <a:r>
+              <a:t>Look at the pictures and discuss the activities you see.</a:t>
+            </a:r>
+          </a:p>
+        </p:txBody>
+      </p:sp>
+    </p:spTree>
+  </p:cSld>
+  <p:clrMapOvr>
+    <a:masterClrMapping/>
+  </p:clrMapOvr>
+</p:sld>
+</file>
+
 <file path=ppt/slides/slide41.xml><?xml version="1.0" encoding="utf-8"?>
 <p:sld xmlns:a="http://schemas.openxmlformats.org/drawingml/2006/main" xmlns:p="http://schemas.openxmlformats.org/presentationml/2006/main" xmlns:r="http://schemas.openxmlformats.org/officeDocument/2006/relationships">
   <p:cSld>
@@ -5966,7 +5976,7 @@
           <a:lstStyle/>
           <a:p>
             <a:r>
-              <a:t>Stage 5: Group Discussion</a:t>
+              <a:t>Task 2: Reading Comprehension - Multiple Choice</a:t>
             </a:r>
           </a:p>
         </p:txBody>
@@ -5989,7 +5999,7 @@
           <a:p>
             <a:pPr/>
             <a:r>
-              <a:t>Discuss your preferences regarding leisure activities and report back to the class.</a:t>
+              <a:t>Read a text about Trang's leisure activities and answer multiple choice questions.</a:t>
             </a:r>
           </a:p>
         </p:txBody>
@@ -6028,7 +6038,7 @@
           <a:lstStyle/>
           <a:p>
             <a:r>
-              <a:t>Wrap-up</a:t>
+              <a:t>Task 3: Vocabulary Focus</a:t>
             </a:r>
           </a:p>
         </p:txBody>
@@ -6051,7 +6061,7 @@
           <a:p>
             <a:pPr/>
             <a:r>
-              <a:t>Summarize the lesson and address any questions.</a:t>
+              <a:t>The word 'connect' is closest in meaning to ______.</a:t>
             </a:r>
           </a:p>
         </p:txBody>
@@ -6090,7 +6100,7 @@
           <a:lstStyle/>
           <a:p>
             <a:r>
-              <a:t>Unit 1 - Leisure Time</a:t>
+              <a:t>Task 4: Detailed Reading and Question Answering</a:t>
             </a:r>
           </a:p>
         </p:txBody>
@@ -6102,27 +6112,6 @@
             <a:spLocks noGrp="1"/>
           </p:cNvSpPr>
           <p:nvPr>
-            <p:ph type="body" idx="10" sz="quarter"/>
-          </p:nvPr>
-        </p:nvSpPr>
-        <p:spPr/>
-        <p:txBody>
-          <a:bodyPr/>
-          <a:lstStyle/>
-          <a:p>
-            <a:r>
-              <a:t>Skills 1</a:t>
-            </a:r>
-          </a:p>
-        </p:txBody>
-      </p:sp>
-      <p:sp>
-        <p:nvSpPr>
-          <p:cNvPr id="4" name="Text Placeholder 3"/>
-          <p:cNvSpPr>
-            <a:spLocks noGrp="1"/>
-          </p:cNvSpPr>
-          <p:nvPr>
             <p:ph type="body" idx="11" sz="quarter"/>
           </p:nvPr>
         </p:nvSpPr>
@@ -6131,6 +6120,12 @@
           <a:bodyPr/>
           <a:lstStyle/>
           <a:p/>
+          <a:p>
+            <a:pPr/>
+            <a:r>
+              <a:t>Read the text again and answer detailed questions about Trang's activities.</a:t>
+            </a:r>
+          </a:p>
         </p:txBody>
       </p:sp>
     </p:spTree>
@@ -6167,7 +6162,7 @@
           <a:lstStyle/>
           <a:p>
             <a:r>
-              <a:t>Warm-up</a:t>
+              <a:t>Task 5: Group Discussion</a:t>
             </a:r>
           </a:p>
         </p:txBody>
@@ -6190,11 +6185,35 @@
           <a:p>
             <a:pPr/>
             <a:r>
-              <a:t>What are your favorite leisure activities with your family?</a:t>
-            </a:r>
-          </a:p>
-        </p:txBody>
-      </p:sp>
+              <a:t>Discuss personal leisure activities in groups and record answers.</a:t>
+            </a:r>
+          </a:p>
+        </p:txBody>
+      </p:sp>
+      <p:pic>
+        <p:nvPicPr>
+          <p:cNvPr id="4" name="Picture 3" descr="image.jpg"/>
+          <p:cNvPicPr>
+            <a:picLocks noChangeAspect="1"/>
+          </p:cNvPicPr>
+          <p:nvPr/>
+        </p:nvPicPr>
+        <p:blipFill>
+          <a:blip r:embed="rId2"/>
+          <a:stretch>
+            <a:fillRect/>
+          </a:stretch>
+        </p:blipFill>
+        <p:spPr>
+          <a:xfrm>
+            <a:off x="914400" y="1828800"/>
+            <a:ext cx="4114800" cy="1345598"/>
+          </a:xfrm>
+          <a:prstGeom prst="rect">
+            <a:avLst/>
+          </a:prstGeom>
+        </p:spPr>
+      </p:pic>
     </p:spTree>
   </p:cSld>
   <p:clrMapOvr>
@@ -6229,7 +6248,7 @@
           <a:lstStyle/>
           <a:p>
             <a:r>
-              <a:t>Stage 1: Look at the Pictures</a:t>
+              <a:t>Task 6: Reporting</a:t>
             </a:r>
           </a:p>
         </p:txBody>
@@ -6252,7 +6271,7 @@
           <a:p>
             <a:pPr/>
             <a:r>
-              <a:t>Look at the pictures and discuss the activities shown.</a:t>
+              <a:t>Report on group members' leisure activities and identify common ones.</a:t>
             </a:r>
           </a:p>
         </p:txBody>
@@ -6291,7 +6310,7 @@
           <a:lstStyle/>
           <a:p>
             <a:r>
-              <a:t>Stage 2: Read about Trang's Leisure Activities</a:t>
+              <a:t>Wrap-up</a:t>
             </a:r>
           </a:p>
         </p:txBody>
@@ -6314,7 +6333,7 @@
           <a:p>
             <a:pPr/>
             <a:r>
-              <a:t>Read about Trang's leisure activities and choose the correct answers for multiple-choice questions.</a:t>
+              <a:t>Summarize the lesson and ask any final questions.</a:t>
             </a:r>
           </a:p>
         </p:txBody>
@@ -6353,7 +6372,7 @@
           <a:lstStyle/>
           <a:p>
             <a:r>
-              <a:t>Stage 3: Read the Text Again and Answer Questions</a:t>
+              <a:t>Unit 1 - Leisure Time</a:t>
             </a:r>
           </a:p>
         </p:txBody>
@@ -6365,6 +6384,27 @@
             <a:spLocks noGrp="1"/>
           </p:cNvSpPr>
           <p:nvPr>
+            <p:ph type="body" idx="10" sz="quarter"/>
+          </p:nvPr>
+        </p:nvSpPr>
+        <p:spPr/>
+        <p:txBody>
+          <a:bodyPr/>
+          <a:lstStyle/>
+          <a:p>
+            <a:r>
+              <a:t>Skills 2</a:t>
+            </a:r>
+          </a:p>
+        </p:txBody>
+      </p:sp>
+      <p:sp>
+        <p:nvSpPr>
+          <p:cNvPr id="4" name="Text Placeholder 3"/>
+          <p:cNvSpPr>
+            <a:spLocks noGrp="1"/>
+          </p:cNvSpPr>
+          <p:nvPr>
             <p:ph type="body" idx="11" sz="quarter"/>
           </p:nvPr>
         </p:nvSpPr>
@@ -6373,12 +6413,6 @@
           <a:bodyPr/>
           <a:lstStyle/>
           <a:p/>
-          <a:p>
-            <a:pPr/>
-            <a:r>
-              <a:t>Read the text again and answer specific questions.</a:t>
-            </a:r>
-          </a:p>
         </p:txBody>
       </p:sp>
     </p:spTree>
@@ -6415,7 +6449,7 @@
           <a:lstStyle/>
           <a:p>
             <a:r>
-              <a:t>Stage 4: Work in Groups</a:t>
+              <a:t>Warm-up</a:t>
             </a:r>
           </a:p>
         </p:txBody>
@@ -6438,7 +6472,7 @@
           <a:p>
             <a:pPr/>
             <a:r>
-              <a:t>Discuss and record answers to questions about your leisure activities with family.</a:t>
+              <a:t>What are your favorite leisure activities with friends?</a:t>
             </a:r>
           </a:p>
         </p:txBody>
@@ -6477,7 +6511,7 @@
           <a:lstStyle/>
           <a:p>
             <a:r>
-              <a:t>Stage 5: Report Answers to the Class</a:t>
+              <a:t>Stage 1: Answer the Questions</a:t>
             </a:r>
           </a:p>
         </p:txBody>
@@ -6500,7 +6534,13 @@
           <a:p>
             <a:pPr/>
             <a:r>
-              <a:t>Report your findings to the class and discuss the most common activities.</a:t>
+              <a:t>In your opinion, what activities can we do with our friends in our leisure time?</a:t>
+            </a:r>
+          </a:p>
+          <a:p>
+            <a:pPr/>
+            <a:r>
+              <a:t>Why should we spend time with our friends?</a:t>
             </a:r>
           </a:p>
         </p:txBody>
@@ -6768,7 +6808,7 @@
           <a:lstStyle/>
           <a:p>
             <a:r>
-              <a:t>Wrap-up</a:t>
+              <a:t>Stage 2: Listen and Choose the Correct Answer</a:t>
             </a:r>
           </a:p>
         </p:txBody>
@@ -6791,7 +6831,19 @@
           <a:p>
             <a:pPr/>
             <a:r>
-              <a:t>Summarize the lesson and address any questions.</a:t>
+              <a:t>Listen to an interview with Mark and choose the correct answers to the questions.</a:t>
+            </a:r>
+          </a:p>
+          <a:p>
+            <a:pPr/>
+            <a:r>
+              <a:t>When does Mark usually have free time?</a:t>
+            </a:r>
+          </a:p>
+          <a:p>
+            <a:pPr/>
+            <a:r>
+              <a:t>Who does he spend his free time with?</a:t>
             </a:r>
           </a:p>
         </p:txBody>
@@ -6830,7 +6882,7 @@
           <a:lstStyle/>
           <a:p>
             <a:r>
-              <a:t>Unit 1 - Leisure Time</a:t>
+              <a:t>Stage 3: Listen Again and Fill in the Blanks</a:t>
             </a:r>
           </a:p>
         </p:txBody>
@@ -6842,27 +6894,6 @@
             <a:spLocks noGrp="1"/>
           </p:cNvSpPr>
           <p:nvPr>
-            <p:ph type="body" idx="10" sz="quarter"/>
-          </p:nvPr>
-        </p:nvSpPr>
-        <p:spPr/>
-        <p:txBody>
-          <a:bodyPr/>
-          <a:lstStyle/>
-          <a:p>
-            <a:r>
-              <a:t>Skills 2</a:t>
-            </a:r>
-          </a:p>
-        </p:txBody>
-      </p:sp>
-      <p:sp>
-        <p:nvSpPr>
-          <p:cNvPr id="4" name="Text Placeholder 3"/>
-          <p:cNvSpPr>
-            <a:spLocks noGrp="1"/>
-          </p:cNvSpPr>
-          <p:nvPr>
             <p:ph type="body" idx="11" sz="quarter"/>
           </p:nvPr>
         </p:nvSpPr>
@@ -6871,258 +6902,10 @@
           <a:bodyPr/>
           <a:lstStyle/>
           <a:p/>
-        </p:txBody>
-      </p:sp>
-    </p:spTree>
-  </p:cSld>
-  <p:clrMapOvr>
-    <a:masterClrMapping/>
-  </p:clrMapOvr>
-</p:sld>
-</file>
-
-<file path=ppt/slides/slide52.xml><?xml version="1.0" encoding="utf-8"?>
-<p:sld xmlns:a="http://schemas.openxmlformats.org/drawingml/2006/main" xmlns:p="http://schemas.openxmlformats.org/presentationml/2006/main" xmlns:r="http://schemas.openxmlformats.org/officeDocument/2006/relationships">
-  <p:cSld>
-    <p:spTree>
-      <p:nvGrpSpPr>
-        <p:cNvPr id="1" name=""/>
-        <p:cNvGrpSpPr/>
-        <p:nvPr/>
-      </p:nvGrpSpPr>
-      <p:grpSpPr/>
-      <p:sp>
-        <p:nvSpPr>
-          <p:cNvPr id="2" name="Title 1"/>
-          <p:cNvSpPr>
-            <a:spLocks noGrp="1"/>
-          </p:cNvSpPr>
-          <p:nvPr>
-            <p:ph type="title"/>
-          </p:nvPr>
-        </p:nvSpPr>
-        <p:spPr/>
-        <p:txBody>
-          <a:bodyPr/>
-          <a:lstStyle/>
-          <a:p>
-            <a:r>
-              <a:t>Warm-up</a:t>
-            </a:r>
-          </a:p>
-        </p:txBody>
-      </p:sp>
-      <p:sp>
-        <p:nvSpPr>
-          <p:cNvPr id="3" name="Text Placeholder 2"/>
-          <p:cNvSpPr>
-            <a:spLocks noGrp="1"/>
-          </p:cNvSpPr>
-          <p:nvPr>
-            <p:ph type="body" idx="11" sz="quarter"/>
-          </p:nvPr>
-        </p:nvSpPr>
-        <p:spPr/>
-        <p:txBody>
-          <a:bodyPr/>
-          <a:lstStyle/>
-          <a:p/>
           <a:p>
             <a:pPr/>
             <a:r>
-              <a:t>What are your favorite activities to do with friends during leisure time?</a:t>
-            </a:r>
-          </a:p>
-        </p:txBody>
-      </p:sp>
-    </p:spTree>
-  </p:cSld>
-  <p:clrMapOvr>
-    <a:masterClrMapping/>
-  </p:clrMapOvr>
-</p:sld>
-</file>
-
-<file path=ppt/slides/slide53.xml><?xml version="1.0" encoding="utf-8"?>
-<p:sld xmlns:a="http://schemas.openxmlformats.org/drawingml/2006/main" xmlns:p="http://schemas.openxmlformats.org/presentationml/2006/main" xmlns:r="http://schemas.openxmlformats.org/officeDocument/2006/relationships">
-  <p:cSld>
-    <p:spTree>
-      <p:nvGrpSpPr>
-        <p:cNvPr id="1" name=""/>
-        <p:cNvGrpSpPr/>
-        <p:nvPr/>
-      </p:nvGrpSpPr>
-      <p:grpSpPr/>
-      <p:sp>
-        <p:nvSpPr>
-          <p:cNvPr id="2" name="Title 1"/>
-          <p:cNvSpPr>
-            <a:spLocks noGrp="1"/>
-          </p:cNvSpPr>
-          <p:nvPr>
-            <p:ph type="title"/>
-          </p:nvPr>
-        </p:nvSpPr>
-        <p:spPr/>
-        <p:txBody>
-          <a:bodyPr/>
-          <a:lstStyle/>
-          <a:p>
-            <a:r>
-              <a:t>Stage 1: Answer the Questions</a:t>
-            </a:r>
-          </a:p>
-        </p:txBody>
-      </p:sp>
-      <p:sp>
-        <p:nvSpPr>
-          <p:cNvPr id="3" name="Text Placeholder 2"/>
-          <p:cNvSpPr>
-            <a:spLocks noGrp="1"/>
-          </p:cNvSpPr>
-          <p:nvPr>
-            <p:ph type="body" idx="11" sz="quarter"/>
-          </p:nvPr>
-        </p:nvSpPr>
-        <p:spPr/>
-        <p:txBody>
-          <a:bodyPr/>
-          <a:lstStyle/>
-          <a:p/>
-          <a:p>
-            <a:pPr/>
-            <a:r>
-              <a:t>What activities can we do with our friends in our leisure time?</a:t>
-            </a:r>
-          </a:p>
-          <a:p>
-            <a:pPr/>
-            <a:r>
-              <a:t>Why should we spend time with our friends?</a:t>
-            </a:r>
-          </a:p>
-        </p:txBody>
-      </p:sp>
-    </p:spTree>
-  </p:cSld>
-  <p:clrMapOvr>
-    <a:masterClrMapping/>
-  </p:clrMapOvr>
-</p:sld>
-</file>
-
-<file path=ppt/slides/slide54.xml><?xml version="1.0" encoding="utf-8"?>
-<p:sld xmlns:a="http://schemas.openxmlformats.org/drawingml/2006/main" xmlns:p="http://schemas.openxmlformats.org/presentationml/2006/main" xmlns:r="http://schemas.openxmlformats.org/officeDocument/2006/relationships">
-  <p:cSld>
-    <p:spTree>
-      <p:nvGrpSpPr>
-        <p:cNvPr id="1" name=""/>
-        <p:cNvGrpSpPr/>
-        <p:nvPr/>
-      </p:nvGrpSpPr>
-      <p:grpSpPr/>
-      <p:sp>
-        <p:nvSpPr>
-          <p:cNvPr id="2" name="Title 1"/>
-          <p:cNvSpPr>
-            <a:spLocks noGrp="1"/>
-          </p:cNvSpPr>
-          <p:nvPr>
-            <p:ph type="title"/>
-          </p:nvPr>
-        </p:nvSpPr>
-        <p:spPr/>
-        <p:txBody>
-          <a:bodyPr/>
-          <a:lstStyle/>
-          <a:p>
-            <a:r>
-              <a:t>Stage 2: Listen to an Interview</a:t>
-            </a:r>
-          </a:p>
-        </p:txBody>
-      </p:sp>
-      <p:sp>
-        <p:nvSpPr>
-          <p:cNvPr id="3" name="Text Placeholder 2"/>
-          <p:cNvSpPr>
-            <a:spLocks noGrp="1"/>
-          </p:cNvSpPr>
-          <p:nvPr>
-            <p:ph type="body" idx="11" sz="quarter"/>
-          </p:nvPr>
-        </p:nvSpPr>
-        <p:spPr/>
-        <p:txBody>
-          <a:bodyPr/>
-          <a:lstStyle/>
-          <a:p/>
-          <a:p>
-            <a:pPr/>
-            <a:r>
-              <a:t>Listen to an interview with Mark and choose the correct answers for multiple-choice questions.</a:t>
-            </a:r>
-          </a:p>
-        </p:txBody>
-      </p:sp>
-    </p:spTree>
-  </p:cSld>
-  <p:clrMapOvr>
-    <a:masterClrMapping/>
-  </p:clrMapOvr>
-</p:sld>
-</file>
-
-<file path=ppt/slides/slide55.xml><?xml version="1.0" encoding="utf-8"?>
-<p:sld xmlns:a="http://schemas.openxmlformats.org/drawingml/2006/main" xmlns:p="http://schemas.openxmlformats.org/presentationml/2006/main" xmlns:r="http://schemas.openxmlformats.org/officeDocument/2006/relationships">
-  <p:cSld>
-    <p:spTree>
-      <p:nvGrpSpPr>
-        <p:cNvPr id="1" name=""/>
-        <p:cNvGrpSpPr/>
-        <p:nvPr/>
-      </p:nvGrpSpPr>
-      <p:grpSpPr/>
-      <p:sp>
-        <p:nvSpPr>
-          <p:cNvPr id="2" name="Title 1"/>
-          <p:cNvSpPr>
-            <a:spLocks noGrp="1"/>
-          </p:cNvSpPr>
-          <p:nvPr>
-            <p:ph type="title"/>
-          </p:nvPr>
-        </p:nvSpPr>
-        <p:spPr/>
-        <p:txBody>
-          <a:bodyPr/>
-          <a:lstStyle/>
-          <a:p>
-            <a:r>
-              <a:t>Stage 3: Listen Again and Fill in the Blanks</a:t>
-            </a:r>
-          </a:p>
-        </p:txBody>
-      </p:sp>
-      <p:sp>
-        <p:nvSpPr>
-          <p:cNvPr id="3" name="Text Placeholder 2"/>
-          <p:cNvSpPr>
-            <a:spLocks noGrp="1"/>
-          </p:cNvSpPr>
-          <p:nvPr>
-            <p:ph type="body" idx="11" sz="quarter"/>
-          </p:nvPr>
-        </p:nvSpPr>
-        <p:spPr/>
-        <p:txBody>
-          <a:bodyPr/>
-          <a:lstStyle/>
-          <a:p/>
-          <a:p>
-            <a:pPr/>
-            <a:r>
-              <a:t>Listen to the interview again and fill in the blanks in a table with no more than TWO words.</a:t>
+              <a:t>Listen to the interview again and fill in the blanks in the table.</a:t>
             </a:r>
           </a:p>
         </p:txBody>
@@ -7159,7 +6942,7 @@
 </p:sld>
 </file>
 
-<file path=ppt/slides/slide56.xml><?xml version="1.0" encoding="utf-8"?>
+<file path=ppt/slides/slide52.xml><?xml version="1.0" encoding="utf-8"?>
 <p:sld xmlns:a="http://schemas.openxmlformats.org/drawingml/2006/main" xmlns:p="http://schemas.openxmlformats.org/presentationml/2006/main" xmlns:r="http://schemas.openxmlformats.org/officeDocument/2006/relationships">
   <p:cSld>
     <p:spTree>
@@ -7185,7 +6968,7 @@
           <a:lstStyle/>
           <a:p>
             <a:r>
-              <a:t>Stage 4: Work in Pairs</a:t>
+              <a:t>Stage 4: Pair Work - Ask and Answer Questions</a:t>
             </a:r>
           </a:p>
         </p:txBody>
@@ -7208,7 +6991,7 @@
           <a:p>
             <a:pPr/>
             <a:r>
-              <a:t>Ask and answer questions about your leisure activities with friends.</a:t>
+              <a:t>Work in pairs to ask and answer questions about free time activities.</a:t>
             </a:r>
           </a:p>
           <a:p>
@@ -7239,7 +7022,7 @@
 </p:sld>
 </file>
 
-<file path=ppt/slides/slide57.xml><?xml version="1.0" encoding="utf-8"?>
+<file path=ppt/slides/slide53.xml><?xml version="1.0" encoding="utf-8"?>
 <p:sld xmlns:a="http://schemas.openxmlformats.org/drawingml/2006/main" xmlns:p="http://schemas.openxmlformats.org/presentationml/2006/main" xmlns:r="http://schemas.openxmlformats.org/officeDocument/2006/relationships">
   <p:cSld>
     <p:spTree>
@@ -7265,7 +7048,7 @@
           <a:lstStyle/>
           <a:p>
             <a:r>
-              <a:t>Stage 5: Write an Email</a:t>
+              <a:t>Stage 5: Write an Email to a Penfriend</a:t>
             </a:r>
           </a:p>
         </p:txBody>
@@ -7288,49 +7071,7 @@
           <a:p>
             <a:pPr/>
             <a:r>
-              <a:t>Write an email to a penfriend describing your leisure activities with friends, using your answers from the previous task.</a:t>
-            </a:r>
-          </a:p>
-          <a:p>
-            <a:pPr/>
-            <a:r>
-              <a:t>From:</a:t>
-            </a:r>
-          </a:p>
-          <a:p>
-            <a:pPr/>
-            <a:r>
-              <a:t>To:</a:t>
-            </a:r>
-          </a:p>
-          <a:p>
-            <a:pPr/>
-            <a:r>
-              <a:t>Subject: My free time</a:t>
-            </a:r>
-          </a:p>
-          <a:p>
-            <a:pPr/>
-            <a:r>
-              <a:t>Hi ________,</a:t>
-            </a:r>
-          </a:p>
-          <a:p>
-            <a:pPr/>
-            <a:r>
-              <a:t>It's nice to hear from you again.</a:t>
-            </a:r>
-          </a:p>
-          <a:p>
-            <a:pPr/>
-            <a:r>
-              <a:t>Let me tell you about ______________.</a:t>
-            </a:r>
-          </a:p>
-          <a:p>
-            <a:pPr/>
-            <a:r>
-              <a:t>Bye for now,</a:t>
+              <a:t>Write an email to a penfriend about what you usually do with friends in your free time.</a:t>
             </a:r>
           </a:p>
         </p:txBody>
@@ -7367,6 +7108,275 @@
 </p:sld>
 </file>
 
+<file path=ppt/slides/slide54.xml><?xml version="1.0" encoding="utf-8"?>
+<p:sld xmlns:a="http://schemas.openxmlformats.org/drawingml/2006/main" xmlns:p="http://schemas.openxmlformats.org/presentationml/2006/main" xmlns:r="http://schemas.openxmlformats.org/officeDocument/2006/relationships">
+  <p:cSld>
+    <p:spTree>
+      <p:nvGrpSpPr>
+        <p:cNvPr id="1" name=""/>
+        <p:cNvGrpSpPr/>
+        <p:nvPr/>
+      </p:nvGrpSpPr>
+      <p:grpSpPr/>
+      <p:sp>
+        <p:nvSpPr>
+          <p:cNvPr id="2" name="Title 1"/>
+          <p:cNvSpPr>
+            <a:spLocks noGrp="1"/>
+          </p:cNvSpPr>
+          <p:nvPr>
+            <p:ph type="title"/>
+          </p:nvPr>
+        </p:nvSpPr>
+        <p:spPr/>
+        <p:txBody>
+          <a:bodyPr/>
+          <a:lstStyle/>
+          <a:p>
+            <a:r>
+              <a:t>Wrap-up</a:t>
+            </a:r>
+          </a:p>
+        </p:txBody>
+      </p:sp>
+      <p:sp>
+        <p:nvSpPr>
+          <p:cNvPr id="3" name="Text Placeholder 2"/>
+          <p:cNvSpPr>
+            <a:spLocks noGrp="1"/>
+          </p:cNvSpPr>
+          <p:nvPr>
+            <p:ph type="body" idx="11" sz="quarter"/>
+          </p:nvPr>
+        </p:nvSpPr>
+        <p:spPr/>
+        <p:txBody>
+          <a:bodyPr/>
+          <a:lstStyle/>
+          <a:p/>
+          <a:p>
+            <a:pPr/>
+            <a:r>
+              <a:t>What did you learn about leisure activities?</a:t>
+            </a:r>
+          </a:p>
+          <a:p>
+            <a:pPr/>
+            <a:r>
+              <a:t>How can you spend your free time with friends?</a:t>
+            </a:r>
+          </a:p>
+        </p:txBody>
+      </p:sp>
+    </p:spTree>
+  </p:cSld>
+  <p:clrMapOvr>
+    <a:masterClrMapping/>
+  </p:clrMapOvr>
+</p:sld>
+</file>
+
+<file path=ppt/slides/slide55.xml><?xml version="1.0" encoding="utf-8"?>
+<p:sld xmlns:a="http://schemas.openxmlformats.org/drawingml/2006/main" xmlns:p="http://schemas.openxmlformats.org/presentationml/2006/main" xmlns:r="http://schemas.openxmlformats.org/officeDocument/2006/relationships">
+  <p:cSld>
+    <p:spTree>
+      <p:nvGrpSpPr>
+        <p:cNvPr id="1" name=""/>
+        <p:cNvGrpSpPr/>
+        <p:nvPr/>
+      </p:nvGrpSpPr>
+      <p:grpSpPr/>
+      <p:sp>
+        <p:nvSpPr>
+          <p:cNvPr id="2" name="Title 1"/>
+          <p:cNvSpPr>
+            <a:spLocks noGrp="1"/>
+          </p:cNvSpPr>
+          <p:nvPr>
+            <p:ph type="title"/>
+          </p:nvPr>
+        </p:nvSpPr>
+        <p:spPr/>
+        <p:txBody>
+          <a:bodyPr/>
+          <a:lstStyle/>
+          <a:p>
+            <a:r>
+              <a:t>Leisure Activities</a:t>
+            </a:r>
+          </a:p>
+        </p:txBody>
+      </p:sp>
+      <p:sp>
+        <p:nvSpPr>
+          <p:cNvPr id="3" name="Text Placeholder 2"/>
+          <p:cNvSpPr>
+            <a:spLocks noGrp="1"/>
+          </p:cNvSpPr>
+          <p:nvPr>
+            <p:ph type="body" idx="10" sz="quarter"/>
+          </p:nvPr>
+        </p:nvSpPr>
+        <p:spPr/>
+        <p:txBody>
+          <a:bodyPr/>
+          <a:lstStyle/>
+          <a:p>
+            <a:r>
+              <a:t>Looking Back</a:t>
+            </a:r>
+          </a:p>
+        </p:txBody>
+      </p:sp>
+      <p:sp>
+        <p:nvSpPr>
+          <p:cNvPr id="4" name="Text Placeholder 3"/>
+          <p:cNvSpPr>
+            <a:spLocks noGrp="1"/>
+          </p:cNvSpPr>
+          <p:nvPr>
+            <p:ph type="body" idx="11" sz="quarter"/>
+          </p:nvPr>
+        </p:nvSpPr>
+        <p:spPr/>
+        <p:txBody>
+          <a:bodyPr/>
+          <a:lstStyle/>
+          <a:p/>
+        </p:txBody>
+      </p:sp>
+    </p:spTree>
+  </p:cSld>
+  <p:clrMapOvr>
+    <a:masterClrMapping/>
+  </p:clrMapOvr>
+</p:sld>
+</file>
+
+<file path=ppt/slides/slide56.xml><?xml version="1.0" encoding="utf-8"?>
+<p:sld xmlns:a="http://schemas.openxmlformats.org/drawingml/2006/main" xmlns:p="http://schemas.openxmlformats.org/presentationml/2006/main" xmlns:r="http://schemas.openxmlformats.org/officeDocument/2006/relationships">
+  <p:cSld>
+    <p:spTree>
+      <p:nvGrpSpPr>
+        <p:cNvPr id="1" name=""/>
+        <p:cNvGrpSpPr/>
+        <p:nvPr/>
+      </p:nvGrpSpPr>
+      <p:grpSpPr/>
+      <p:sp>
+        <p:nvSpPr>
+          <p:cNvPr id="2" name="Title 1"/>
+          <p:cNvSpPr>
+            <a:spLocks noGrp="1"/>
+          </p:cNvSpPr>
+          <p:nvPr>
+            <p:ph type="title"/>
+          </p:nvPr>
+        </p:nvSpPr>
+        <p:spPr/>
+        <p:txBody>
+          <a:bodyPr/>
+          <a:lstStyle/>
+          <a:p>
+            <a:r>
+              <a:t>Warm-up</a:t>
+            </a:r>
+          </a:p>
+        </p:txBody>
+      </p:sp>
+      <p:sp>
+        <p:nvSpPr>
+          <p:cNvPr id="3" name="Text Placeholder 2"/>
+          <p:cNvSpPr>
+            <a:spLocks noGrp="1"/>
+          </p:cNvSpPr>
+          <p:nvPr>
+            <p:ph type="body" idx="11" sz="quarter"/>
+          </p:nvPr>
+        </p:nvSpPr>
+        <p:spPr/>
+        <p:txBody>
+          <a:bodyPr/>
+          <a:lstStyle/>
+          <a:p/>
+          <a:p>
+            <a:pPr/>
+            <a:r>
+              <a:t>Introduction to the topic of leisure activities.</a:t>
+            </a:r>
+          </a:p>
+        </p:txBody>
+      </p:sp>
+    </p:spTree>
+  </p:cSld>
+  <p:clrMapOvr>
+    <a:masterClrMapping/>
+  </p:clrMapOvr>
+</p:sld>
+</file>
+
+<file path=ppt/slides/slide57.xml><?xml version="1.0" encoding="utf-8"?>
+<p:sld xmlns:a="http://schemas.openxmlformats.org/drawingml/2006/main" xmlns:p="http://schemas.openxmlformats.org/presentationml/2006/main" xmlns:r="http://schemas.openxmlformats.org/officeDocument/2006/relationships">
+  <p:cSld>
+    <p:spTree>
+      <p:nvGrpSpPr>
+        <p:cNvPr id="1" name=""/>
+        <p:cNvGrpSpPr/>
+        <p:nvPr/>
+      </p:nvGrpSpPr>
+      <p:grpSpPr/>
+      <p:sp>
+        <p:nvSpPr>
+          <p:cNvPr id="2" name="Title 1"/>
+          <p:cNvSpPr>
+            <a:spLocks noGrp="1"/>
+          </p:cNvSpPr>
+          <p:nvPr>
+            <p:ph type="title"/>
+          </p:nvPr>
+        </p:nvSpPr>
+        <p:spPr/>
+        <p:txBody>
+          <a:bodyPr/>
+          <a:lstStyle/>
+          <a:p>
+            <a:r>
+              <a:t>Vocabulary Task 1</a:t>
+            </a:r>
+          </a:p>
+        </p:txBody>
+      </p:sp>
+      <p:sp>
+        <p:nvSpPr>
+          <p:cNvPr id="3" name="Text Placeholder 2"/>
+          <p:cNvSpPr>
+            <a:spLocks noGrp="1"/>
+          </p:cNvSpPr>
+          <p:nvPr>
+            <p:ph type="body" idx="11" sz="quarter"/>
+          </p:nvPr>
+        </p:nvSpPr>
+        <p:spPr/>
+        <p:txBody>
+          <a:bodyPr/>
+          <a:lstStyle/>
+          <a:p/>
+          <a:p>
+            <a:pPr/>
+            <a:r>
+              <a:t>Complete the sentences with appropriate leisure activities.</a:t>
+            </a:r>
+          </a:p>
+        </p:txBody>
+      </p:sp>
+    </p:spTree>
+  </p:cSld>
+  <p:clrMapOvr>
+    <a:masterClrMapping/>
+  </p:clrMapOvr>
+</p:sld>
+</file>
+
 <file path=ppt/slides/slide58.xml><?xml version="1.0" encoding="utf-8"?>
 <p:sld xmlns:a="http://schemas.openxmlformats.org/drawingml/2006/main" xmlns:p="http://schemas.openxmlformats.org/presentationml/2006/main" xmlns:r="http://schemas.openxmlformats.org/officeDocument/2006/relationships">
   <p:cSld>
@@ -7393,7 +7403,7 @@
           <a:lstStyle/>
           <a:p>
             <a:r>
-              <a:t>Wrap-up</a:t>
+              <a:t>Writing Task 2</a:t>
             </a:r>
           </a:p>
         </p:txBody>
@@ -7416,7 +7426,7 @@
           <a:p>
             <a:pPr/>
             <a:r>
-              <a:t>Summarize the lesson and address any questions.</a:t>
+              <a:t>Write complete sentences from the given cues.</a:t>
             </a:r>
           </a:p>
         </p:txBody>
@@ -7455,7 +7465,7 @@
           <a:lstStyle/>
           <a:p>
             <a:r>
-              <a:t>Unit 1 - Leisure Time</a:t>
+              <a:t>Grammar Task 3</a:t>
             </a:r>
           </a:p>
         </p:txBody>
@@ -7467,27 +7477,6 @@
             <a:spLocks noGrp="1"/>
           </p:cNvSpPr>
           <p:nvPr>
-            <p:ph type="body" idx="10" sz="quarter"/>
-          </p:nvPr>
-        </p:nvSpPr>
-        <p:spPr/>
-        <p:txBody>
-          <a:bodyPr/>
-          <a:lstStyle/>
-          <a:p>
-            <a:r>
-              <a:t>Looking Back</a:t>
-            </a:r>
-          </a:p>
-        </p:txBody>
-      </p:sp>
-      <p:sp>
-        <p:nvSpPr>
-          <p:cNvPr id="4" name="Text Placeholder 3"/>
-          <p:cNvSpPr>
-            <a:spLocks noGrp="1"/>
-          </p:cNvSpPr>
-          <p:nvPr>
             <p:ph type="body" idx="11" sz="quarter"/>
           </p:nvPr>
         </p:nvSpPr>
@@ -7496,6 +7485,12 @@
           <a:bodyPr/>
           <a:lstStyle/>
           <a:p/>
+          <a:p>
+            <a:pPr/>
+            <a:r>
+              <a:t>Fill in each blank with the correct form(s) of the verb in brackets.</a:t>
+            </a:r>
+          </a:p>
         </p:txBody>
       </p:sp>
     </p:spTree>
@@ -7887,7 +7882,7 @@
           <a:lstStyle/>
           <a:p>
             <a:r>
-              <a:t>Warm-up</a:t>
+              <a:t>Grammar Task 4</a:t>
             </a:r>
           </a:p>
         </p:txBody>
@@ -7910,327 +7905,7 @@
           <a:p>
             <a:pPr/>
             <a:r>
-              <a:t>What are your favorite leisure activities?</a:t>
-            </a:r>
-          </a:p>
-        </p:txBody>
-      </p:sp>
-    </p:spTree>
-  </p:cSld>
-  <p:clrMapOvr>
-    <a:masterClrMapping/>
-  </p:clrMapOvr>
-</p:sld>
-</file>
-
-<file path=ppt/slides/slide61.xml><?xml version="1.0" encoding="utf-8"?>
-<p:sld xmlns:a="http://schemas.openxmlformats.org/drawingml/2006/main" xmlns:p="http://schemas.openxmlformats.org/presentationml/2006/main" xmlns:r="http://schemas.openxmlformats.org/officeDocument/2006/relationships">
-  <p:cSld>
-    <p:spTree>
-      <p:nvGrpSpPr>
-        <p:cNvPr id="1" name=""/>
-        <p:cNvGrpSpPr/>
-        <p:nvPr/>
-      </p:nvGrpSpPr>
-      <p:grpSpPr/>
-      <p:sp>
-        <p:nvSpPr>
-          <p:cNvPr id="2" name="Title 1"/>
-          <p:cNvSpPr>
-            <a:spLocks noGrp="1"/>
-          </p:cNvSpPr>
-          <p:nvPr>
-            <p:ph type="title"/>
-          </p:nvPr>
-        </p:nvSpPr>
-        <p:spPr/>
-        <p:txBody>
-          <a:bodyPr/>
-          <a:lstStyle/>
-          <a:p>
-            <a:r>
-              <a:t>Stage 1: Complete the Sentences</a:t>
-            </a:r>
-          </a:p>
-        </p:txBody>
-      </p:sp>
-      <p:sp>
-        <p:nvSpPr>
-          <p:cNvPr id="3" name="Text Placeholder 2"/>
-          <p:cNvSpPr>
-            <a:spLocks noGrp="1"/>
-          </p:cNvSpPr>
-          <p:nvPr>
-            <p:ph type="body" idx="11" sz="quarter"/>
-          </p:nvPr>
-        </p:nvSpPr>
-        <p:spPr/>
-        <p:txBody>
-          <a:bodyPr/>
-          <a:lstStyle/>
-          <a:p/>
-          <a:p>
-            <a:pPr/>
-            <a:r>
-              <a:t>Mai loves __________ online.</a:t>
-            </a:r>
-          </a:p>
-          <a:p>
-            <a:pPr/>
-            <a:r>
-              <a:t>My favourite leisure activity is __________.</a:t>
-            </a:r>
-          </a:p>
-          <a:p>
-            <a:pPr/>
-            <a:r>
-              <a:t>__________ is a popular way for teens.</a:t>
-            </a:r>
-          </a:p>
-          <a:p>
-            <a:pPr/>
-            <a:r>
-              <a:t>My brother is fond of __________.</a:t>
-            </a:r>
-          </a:p>
-          <a:p>
-            <a:pPr/>
-            <a:r>
-              <a:t>Tom is keen on __________.</a:t>
-            </a:r>
-          </a:p>
-        </p:txBody>
-      </p:sp>
-    </p:spTree>
-  </p:cSld>
-  <p:clrMapOvr>
-    <a:masterClrMapping/>
-  </p:clrMapOvr>
-</p:sld>
-</file>
-
-<file path=ppt/slides/slide62.xml><?xml version="1.0" encoding="utf-8"?>
-<p:sld xmlns:a="http://schemas.openxmlformats.org/drawingml/2006/main" xmlns:p="http://schemas.openxmlformats.org/presentationml/2006/main" xmlns:r="http://schemas.openxmlformats.org/officeDocument/2006/relationships">
-  <p:cSld>
-    <p:spTree>
-      <p:nvGrpSpPr>
-        <p:cNvPr id="1" name=""/>
-        <p:cNvGrpSpPr/>
-        <p:nvPr/>
-      </p:nvGrpSpPr>
-      <p:grpSpPr/>
-      <p:sp>
-        <p:nvSpPr>
-          <p:cNvPr id="2" name="Title 1"/>
-          <p:cNvSpPr>
-            <a:spLocks noGrp="1"/>
-          </p:cNvSpPr>
-          <p:nvPr>
-            <p:ph type="title"/>
-          </p:nvPr>
-        </p:nvSpPr>
-        <p:spPr/>
-        <p:txBody>
-          <a:bodyPr/>
-          <a:lstStyle/>
-          <a:p>
-            <a:r>
-              <a:t>Stage 2: Write Complete Sentences</a:t>
-            </a:r>
-          </a:p>
-        </p:txBody>
-      </p:sp>
-      <p:sp>
-        <p:nvSpPr>
-          <p:cNvPr id="3" name="Text Placeholder 2"/>
-          <p:cNvSpPr>
-            <a:spLocks noGrp="1"/>
-          </p:cNvSpPr>
-          <p:nvPr>
-            <p:ph type="body" idx="11" sz="quarter"/>
-          </p:nvPr>
-        </p:nvSpPr>
-        <p:spPr/>
-        <p:txBody>
-          <a:bodyPr/>
-          <a:lstStyle/>
-          <a:p/>
-          <a:p>
-            <a:pPr/>
-            <a:r>
-              <a:t>my cousin / crazy about / play / computer / games</a:t>
-            </a:r>
-          </a:p>
-          <a:p>
-            <a:pPr/>
-            <a:r>
-              <a:t>they / interested / play / badminton / after school?</a:t>
-            </a:r>
-          </a:p>
-          <a:p>
-            <a:pPr/>
-            <a:r>
-              <a:t>I / not fond / make models / because / I / not patient</a:t>
-            </a:r>
-          </a:p>
-          <a:p>
-            <a:pPr/>
-            <a:r>
-              <a:t>why / you / not into / cook?</a:t>
-            </a:r>
-          </a:p>
-          <a:p>
-            <a:pPr/>
-            <a:r>
-              <a:t>my friends / keen / do judo</a:t>
-            </a:r>
-          </a:p>
-        </p:txBody>
-      </p:sp>
-    </p:spTree>
-  </p:cSld>
-  <p:clrMapOvr>
-    <a:masterClrMapping/>
-  </p:clrMapOvr>
-</p:sld>
-</file>
-
-<file path=ppt/slides/slide63.xml><?xml version="1.0" encoding="utf-8"?>
-<p:sld xmlns:a="http://schemas.openxmlformats.org/drawingml/2006/main" xmlns:p="http://schemas.openxmlformats.org/presentationml/2006/main" xmlns:r="http://schemas.openxmlformats.org/officeDocument/2006/relationships">
-  <p:cSld>
-    <p:spTree>
-      <p:nvGrpSpPr>
-        <p:cNvPr id="1" name=""/>
-        <p:cNvGrpSpPr/>
-        <p:nvPr/>
-      </p:nvGrpSpPr>
-      <p:grpSpPr/>
-      <p:sp>
-        <p:nvSpPr>
-          <p:cNvPr id="2" name="Title 1"/>
-          <p:cNvSpPr>
-            <a:spLocks noGrp="1"/>
-          </p:cNvSpPr>
-          <p:nvPr>
-            <p:ph type="title"/>
-          </p:nvPr>
-        </p:nvSpPr>
-        <p:spPr/>
-        <p:txBody>
-          <a:bodyPr/>
-          <a:lstStyle/>
-          <a:p>
-            <a:r>
-              <a:t>Stage 3: Fill in the Blanks</a:t>
-            </a:r>
-          </a:p>
-        </p:txBody>
-      </p:sp>
-      <p:sp>
-        <p:nvSpPr>
-          <p:cNvPr id="3" name="Text Placeholder 2"/>
-          <p:cNvSpPr>
-            <a:spLocks noGrp="1"/>
-          </p:cNvSpPr>
-          <p:nvPr>
-            <p:ph type="body" idx="11" sz="quarter"/>
-          </p:nvPr>
-        </p:nvSpPr>
-        <p:spPr/>
-        <p:txBody>
-          <a:bodyPr/>
-          <a:lstStyle/>
-          <a:p/>
-          <a:p>
-            <a:pPr/>
-            <a:r>
-              <a:t>Does Tom enjoy (cycle)?</a:t>
-            </a:r>
-          </a:p>
-          <a:p>
-            <a:pPr/>
-            <a:r>
-              <a:t>don’t like (read)?</a:t>
-            </a:r>
-          </a:p>
-          <a:p>
-            <a:pPr/>
-            <a:r>
-              <a:t>Mai detests (play)?</a:t>
-            </a:r>
-          </a:p>
-          <a:p>
-            <a:pPr/>
-            <a:r>
-              <a:t>Trang and Ann love (chat)?</a:t>
-            </a:r>
-          </a:p>
-          <a:p>
-            <a:pPr/>
-            <a:r>
-              <a:t>Nam and Mark prefer (do)?</a:t>
-            </a:r>
-          </a:p>
-        </p:txBody>
-      </p:sp>
-    </p:spTree>
-  </p:cSld>
-  <p:clrMapOvr>
-    <a:masterClrMapping/>
-  </p:clrMapOvr>
-</p:sld>
-</file>
-
-<file path=ppt/slides/slide64.xml><?xml version="1.0" encoding="utf-8"?>
-<p:sld xmlns:a="http://schemas.openxmlformats.org/drawingml/2006/main" xmlns:p="http://schemas.openxmlformats.org/presentationml/2006/main" xmlns:r="http://schemas.openxmlformats.org/officeDocument/2006/relationships">
-  <p:cSld>
-    <p:spTree>
-      <p:nvGrpSpPr>
-        <p:cNvPr id="1" name=""/>
-        <p:cNvGrpSpPr/>
-        <p:nvPr/>
-      </p:nvGrpSpPr>
-      <p:grpSpPr/>
-      <p:sp>
-        <p:nvSpPr>
-          <p:cNvPr id="2" name="Title 1"/>
-          <p:cNvSpPr>
-            <a:spLocks noGrp="1"/>
-          </p:cNvSpPr>
-          <p:nvPr>
-            <p:ph type="title"/>
-          </p:nvPr>
-        </p:nvSpPr>
-        <p:spPr/>
-        <p:txBody>
-          <a:bodyPr/>
-          <a:lstStyle/>
-          <a:p>
-            <a:r>
-              <a:t>Stage 4: Complete the Passage</a:t>
-            </a:r>
-          </a:p>
-        </p:txBody>
-      </p:sp>
-      <p:sp>
-        <p:nvSpPr>
-          <p:cNvPr id="3" name="Text Placeholder 2"/>
-          <p:cNvSpPr>
-            <a:spLocks noGrp="1"/>
-          </p:cNvSpPr>
-          <p:nvPr>
-            <p:ph type="body" idx="11" sz="quarter"/>
-          </p:nvPr>
-        </p:nvSpPr>
-        <p:spPr/>
-        <p:txBody>
-          <a:bodyPr/>
-          <a:lstStyle/>
-          <a:p/>
-          <a:p>
-            <a:pPr/>
-            <a:r>
-              <a:t>Fill in the blanks in the passage with the correct verb forms.</a:t>
+              <a:t>Complete the passage using the correct form(s) of the verbs in brackets and the pictures.</a:t>
             </a:r>
           </a:p>
         </p:txBody>
@@ -8267,6 +7942,299 @@
 </p:sld>
 </file>
 
+<file path=ppt/slides/slide61.xml><?xml version="1.0" encoding="utf-8"?>
+<p:sld xmlns:a="http://schemas.openxmlformats.org/drawingml/2006/main" xmlns:p="http://schemas.openxmlformats.org/presentationml/2006/main" xmlns:r="http://schemas.openxmlformats.org/officeDocument/2006/relationships">
+  <p:cSld>
+    <p:spTree>
+      <p:nvGrpSpPr>
+        <p:cNvPr id="1" name=""/>
+        <p:cNvGrpSpPr/>
+        <p:nvPr/>
+      </p:nvGrpSpPr>
+      <p:grpSpPr/>
+      <p:sp>
+        <p:nvSpPr>
+          <p:cNvPr id="2" name="Title 1"/>
+          <p:cNvSpPr>
+            <a:spLocks noGrp="1"/>
+          </p:cNvSpPr>
+          <p:nvPr>
+            <p:ph type="title"/>
+          </p:nvPr>
+        </p:nvSpPr>
+        <p:spPr/>
+        <p:txBody>
+          <a:bodyPr/>
+          <a:lstStyle/>
+          <a:p>
+            <a:r>
+              <a:t>Wrap-up</a:t>
+            </a:r>
+          </a:p>
+        </p:txBody>
+      </p:sp>
+      <p:sp>
+        <p:nvSpPr>
+          <p:cNvPr id="3" name="Text Placeholder 2"/>
+          <p:cNvSpPr>
+            <a:spLocks noGrp="1"/>
+          </p:cNvSpPr>
+          <p:nvPr>
+            <p:ph type="body" idx="11" sz="quarter"/>
+          </p:nvPr>
+        </p:nvSpPr>
+        <p:spPr/>
+        <p:txBody>
+          <a:bodyPr/>
+          <a:lstStyle/>
+          <a:p/>
+          <a:p>
+            <a:pPr/>
+            <a:r>
+              <a:t>Review of key vocabulary and grammar points covered in the lesson.</a:t>
+            </a:r>
+          </a:p>
+        </p:txBody>
+      </p:sp>
+    </p:spTree>
+  </p:cSld>
+  <p:clrMapOvr>
+    <a:masterClrMapping/>
+  </p:clrMapOvr>
+</p:sld>
+</file>
+
+<file path=ppt/slides/slide62.xml><?xml version="1.0" encoding="utf-8"?>
+<p:sld xmlns:a="http://schemas.openxmlformats.org/drawingml/2006/main" xmlns:p="http://schemas.openxmlformats.org/presentationml/2006/main" xmlns:r="http://schemas.openxmlformats.org/officeDocument/2006/relationships">
+  <p:cSld>
+    <p:spTree>
+      <p:nvGrpSpPr>
+        <p:cNvPr id="1" name=""/>
+        <p:cNvGrpSpPr/>
+        <p:nvPr/>
+      </p:nvGrpSpPr>
+      <p:grpSpPr/>
+      <p:sp>
+        <p:nvSpPr>
+          <p:cNvPr id="2" name="Title 1"/>
+          <p:cNvSpPr>
+            <a:spLocks noGrp="1"/>
+          </p:cNvSpPr>
+          <p:nvPr>
+            <p:ph type="title"/>
+          </p:nvPr>
+        </p:nvSpPr>
+        <p:spPr/>
+        <p:txBody>
+          <a:bodyPr/>
+          <a:lstStyle/>
+          <a:p>
+            <a:r>
+              <a:t>Unit 1 - Leisure Time</a:t>
+            </a:r>
+          </a:p>
+        </p:txBody>
+      </p:sp>
+      <p:sp>
+        <p:nvSpPr>
+          <p:cNvPr id="3" name="Text Placeholder 2"/>
+          <p:cNvSpPr>
+            <a:spLocks noGrp="1"/>
+          </p:cNvSpPr>
+          <p:nvPr>
+            <p:ph type="body" idx="10" sz="quarter"/>
+          </p:nvPr>
+        </p:nvSpPr>
+        <p:spPr/>
+        <p:txBody>
+          <a:bodyPr/>
+          <a:lstStyle/>
+          <a:p>
+            <a:r>
+              <a:t>Project: Leisure Time Survey</a:t>
+            </a:r>
+          </a:p>
+        </p:txBody>
+      </p:sp>
+      <p:sp>
+        <p:nvSpPr>
+          <p:cNvPr id="4" name="Text Placeholder 3"/>
+          <p:cNvSpPr>
+            <a:spLocks noGrp="1"/>
+          </p:cNvSpPr>
+          <p:nvPr>
+            <p:ph type="body" idx="11" sz="quarter"/>
+          </p:nvPr>
+        </p:nvSpPr>
+        <p:spPr/>
+        <p:txBody>
+          <a:bodyPr/>
+          <a:lstStyle/>
+          <a:p/>
+        </p:txBody>
+      </p:sp>
+    </p:spTree>
+  </p:cSld>
+  <p:clrMapOvr>
+    <a:masterClrMapping/>
+  </p:clrMapOvr>
+</p:sld>
+</file>
+
+<file path=ppt/slides/slide63.xml><?xml version="1.0" encoding="utf-8"?>
+<p:sld xmlns:a="http://schemas.openxmlformats.org/drawingml/2006/main" xmlns:p="http://schemas.openxmlformats.org/presentationml/2006/main" xmlns:r="http://schemas.openxmlformats.org/officeDocument/2006/relationships">
+  <p:cSld>
+    <p:spTree>
+      <p:nvGrpSpPr>
+        <p:cNvPr id="1" name=""/>
+        <p:cNvGrpSpPr/>
+        <p:nvPr/>
+      </p:nvGrpSpPr>
+      <p:grpSpPr/>
+      <p:sp>
+        <p:nvSpPr>
+          <p:cNvPr id="2" name="Title 1"/>
+          <p:cNvSpPr>
+            <a:spLocks noGrp="1"/>
+          </p:cNvSpPr>
+          <p:nvPr>
+            <p:ph type="title"/>
+          </p:nvPr>
+        </p:nvSpPr>
+        <p:spPr/>
+        <p:txBody>
+          <a:bodyPr/>
+          <a:lstStyle/>
+          <a:p>
+            <a:r>
+              <a:t>Warm-up</a:t>
+            </a:r>
+          </a:p>
+        </p:txBody>
+      </p:sp>
+      <p:sp>
+        <p:nvSpPr>
+          <p:cNvPr id="3" name="Text Placeholder 2"/>
+          <p:cNvSpPr>
+            <a:spLocks noGrp="1"/>
+          </p:cNvSpPr>
+          <p:nvPr>
+            <p:ph type="body" idx="11" sz="quarter"/>
+          </p:nvPr>
+        </p:nvSpPr>
+        <p:spPr/>
+        <p:txBody>
+          <a:bodyPr/>
+          <a:lstStyle/>
+          <a:p/>
+          <a:p>
+            <a:pPr/>
+            <a:r>
+              <a:t>What do you usually do in your free time?</a:t>
+            </a:r>
+          </a:p>
+        </p:txBody>
+      </p:sp>
+    </p:spTree>
+  </p:cSld>
+  <p:clrMapOvr>
+    <a:masterClrMapping/>
+  </p:clrMapOvr>
+</p:sld>
+</file>
+
+<file path=ppt/slides/slide64.xml><?xml version="1.0" encoding="utf-8"?>
+<p:sld xmlns:a="http://schemas.openxmlformats.org/drawingml/2006/main" xmlns:p="http://schemas.openxmlformats.org/presentationml/2006/main" xmlns:r="http://schemas.openxmlformats.org/officeDocument/2006/relationships">
+  <p:cSld>
+    <p:spTree>
+      <p:nvGrpSpPr>
+        <p:cNvPr id="1" name=""/>
+        <p:cNvGrpSpPr/>
+        <p:nvPr/>
+      </p:nvGrpSpPr>
+      <p:grpSpPr/>
+      <p:sp>
+        <p:nvSpPr>
+          <p:cNvPr id="2" name="Title 1"/>
+          <p:cNvSpPr>
+            <a:spLocks noGrp="1"/>
+          </p:cNvSpPr>
+          <p:nvPr>
+            <p:ph type="title"/>
+          </p:nvPr>
+        </p:nvSpPr>
+        <p:spPr/>
+        <p:txBody>
+          <a:bodyPr/>
+          <a:lstStyle/>
+          <a:p>
+            <a:r>
+              <a:t>Stage 1: Conduct Interviews</a:t>
+            </a:r>
+          </a:p>
+        </p:txBody>
+      </p:sp>
+      <p:sp>
+        <p:nvSpPr>
+          <p:cNvPr id="3" name="Text Placeholder 2"/>
+          <p:cNvSpPr>
+            <a:spLocks noGrp="1"/>
+          </p:cNvSpPr>
+          <p:nvPr>
+            <p:ph type="body" idx="11" sz="quarter"/>
+          </p:nvPr>
+        </p:nvSpPr>
+        <p:spPr/>
+        <p:txBody>
+          <a:bodyPr/>
+          <a:lstStyle/>
+          <a:p/>
+          <a:p>
+            <a:pPr/>
+            <a:r>
+              <a:t>Form groups and interview classmates using the following questions:</a:t>
+            </a:r>
+          </a:p>
+          <a:p>
+            <a:pPr/>
+            <a:r>
+              <a:t>1. When do you have free time?</a:t>
+            </a:r>
+          </a:p>
+          <a:p>
+            <a:pPr/>
+            <a:r>
+              <a:t>2. What do you like doing with your family in your free time?</a:t>
+            </a:r>
+          </a:p>
+          <a:p>
+            <a:pPr/>
+            <a:r>
+              <a:t>3. What do you like doing with your friends in your free time?</a:t>
+            </a:r>
+          </a:p>
+          <a:p>
+            <a:pPr/>
+            <a:r>
+              <a:t>4. What leisure activities do you like doing on your own?</a:t>
+            </a:r>
+          </a:p>
+          <a:p>
+            <a:pPr/>
+            <a:r>
+              <a:t>5. What leisure activities would you like to try in the future?</a:t>
+            </a:r>
+          </a:p>
+        </p:txBody>
+      </p:sp>
+    </p:spTree>
+  </p:cSld>
+  <p:clrMapOvr>
+    <a:masterClrMapping/>
+  </p:clrMapOvr>
+</p:sld>
+</file>
+
 <file path=ppt/slides/slide65.xml><?xml version="1.0" encoding="utf-8"?>
 <p:sld xmlns:a="http://schemas.openxmlformats.org/drawingml/2006/main" xmlns:p="http://schemas.openxmlformats.org/presentationml/2006/main" xmlns:r="http://schemas.openxmlformats.org/officeDocument/2006/relationships">
   <p:cSld>
@@ -8293,7 +8261,7 @@
           <a:lstStyle/>
           <a:p>
             <a:r>
-              <a:t>Wrap-up</a:t>
+              <a:t>Stage 2: Collect and Organize Data</a:t>
             </a:r>
           </a:p>
         </p:txBody>
@@ -8316,300 +8284,7 @@
           <a:p>
             <a:pPr/>
             <a:r>
-              <a:t>Summarize the lesson and address any questions.</a:t>
-            </a:r>
-          </a:p>
-        </p:txBody>
-      </p:sp>
-    </p:spTree>
-  </p:cSld>
-  <p:clrMapOvr>
-    <a:masterClrMapping/>
-  </p:clrMapOvr>
-</p:sld>
-</file>
-
-<file path=ppt/slides/slide66.xml><?xml version="1.0" encoding="utf-8"?>
-<p:sld xmlns:a="http://schemas.openxmlformats.org/drawingml/2006/main" xmlns:p="http://schemas.openxmlformats.org/presentationml/2006/main" xmlns:r="http://schemas.openxmlformats.org/officeDocument/2006/relationships">
-  <p:cSld>
-    <p:spTree>
-      <p:nvGrpSpPr>
-        <p:cNvPr id="1" name=""/>
-        <p:cNvGrpSpPr/>
-        <p:nvPr/>
-      </p:nvGrpSpPr>
-      <p:grpSpPr/>
-      <p:sp>
-        <p:nvSpPr>
-          <p:cNvPr id="2" name="Title 1"/>
-          <p:cNvSpPr>
-            <a:spLocks noGrp="1"/>
-          </p:cNvSpPr>
-          <p:nvPr>
-            <p:ph type="title"/>
-          </p:nvPr>
-        </p:nvSpPr>
-        <p:spPr/>
-        <p:txBody>
-          <a:bodyPr/>
-          <a:lstStyle/>
-          <a:p>
-            <a:r>
-              <a:t>Unit 1 - Leisure Time</a:t>
-            </a:r>
-          </a:p>
-        </p:txBody>
-      </p:sp>
-      <p:sp>
-        <p:nvSpPr>
-          <p:cNvPr id="3" name="Text Placeholder 2"/>
-          <p:cNvSpPr>
-            <a:spLocks noGrp="1"/>
-          </p:cNvSpPr>
-          <p:nvPr>
-            <p:ph type="body" idx="10" sz="quarter"/>
-          </p:nvPr>
-        </p:nvSpPr>
-        <p:spPr/>
-        <p:txBody>
-          <a:bodyPr/>
-          <a:lstStyle/>
-          <a:p>
-            <a:r>
-              <a:t>Project</a:t>
-            </a:r>
-          </a:p>
-        </p:txBody>
-      </p:sp>
-      <p:sp>
-        <p:nvSpPr>
-          <p:cNvPr id="4" name="Text Placeholder 3"/>
-          <p:cNvSpPr>
-            <a:spLocks noGrp="1"/>
-          </p:cNvSpPr>
-          <p:nvPr>
-            <p:ph type="body" idx="11" sz="quarter"/>
-          </p:nvPr>
-        </p:nvSpPr>
-        <p:spPr/>
-        <p:txBody>
-          <a:bodyPr/>
-          <a:lstStyle/>
-          <a:p/>
-        </p:txBody>
-      </p:sp>
-    </p:spTree>
-  </p:cSld>
-  <p:clrMapOvr>
-    <a:masterClrMapping/>
-  </p:clrMapOvr>
-</p:sld>
-</file>
-
-<file path=ppt/slides/slide67.xml><?xml version="1.0" encoding="utf-8"?>
-<p:sld xmlns:a="http://schemas.openxmlformats.org/drawingml/2006/main" xmlns:p="http://schemas.openxmlformats.org/presentationml/2006/main" xmlns:r="http://schemas.openxmlformats.org/officeDocument/2006/relationships">
-  <p:cSld>
-    <p:spTree>
-      <p:nvGrpSpPr>
-        <p:cNvPr id="1" name=""/>
-        <p:cNvGrpSpPr/>
-        <p:nvPr/>
-      </p:nvGrpSpPr>
-      <p:grpSpPr/>
-      <p:sp>
-        <p:nvSpPr>
-          <p:cNvPr id="2" name="Title 1"/>
-          <p:cNvSpPr>
-            <a:spLocks noGrp="1"/>
-          </p:cNvSpPr>
-          <p:nvPr>
-            <p:ph type="title"/>
-          </p:nvPr>
-        </p:nvSpPr>
-        <p:spPr/>
-        <p:txBody>
-          <a:bodyPr/>
-          <a:lstStyle/>
-          <a:p>
-            <a:r>
-              <a:t>Warm-up</a:t>
-            </a:r>
-          </a:p>
-        </p:txBody>
-      </p:sp>
-      <p:sp>
-        <p:nvSpPr>
-          <p:cNvPr id="3" name="Text Placeholder 2"/>
-          <p:cNvSpPr>
-            <a:spLocks noGrp="1"/>
-          </p:cNvSpPr>
-          <p:nvPr>
-            <p:ph type="body" idx="11" sz="quarter"/>
-          </p:nvPr>
-        </p:nvSpPr>
-        <p:spPr/>
-        <p:txBody>
-          <a:bodyPr/>
-          <a:lstStyle/>
-          <a:p/>
-          <a:p>
-            <a:pPr/>
-            <a:r>
-              <a:t>What are your favorite leisure activities?</a:t>
-            </a:r>
-          </a:p>
-          <a:p>
-            <a:pPr/>
-            <a:r>
-              <a:t>Why are surveys important?</a:t>
-            </a:r>
-          </a:p>
-        </p:txBody>
-      </p:sp>
-    </p:spTree>
-  </p:cSld>
-  <p:clrMapOvr>
-    <a:masterClrMapping/>
-  </p:clrMapOvr>
-</p:sld>
-</file>
-
-<file path=ppt/slides/slide68.xml><?xml version="1.0" encoding="utf-8"?>
-<p:sld xmlns:a="http://schemas.openxmlformats.org/drawingml/2006/main" xmlns:p="http://schemas.openxmlformats.org/presentationml/2006/main" xmlns:r="http://schemas.openxmlformats.org/officeDocument/2006/relationships">
-  <p:cSld>
-    <p:spTree>
-      <p:nvGrpSpPr>
-        <p:cNvPr id="1" name=""/>
-        <p:cNvGrpSpPr/>
-        <p:nvPr/>
-      </p:nvGrpSpPr>
-      <p:grpSpPr/>
-      <p:sp>
-        <p:nvSpPr>
-          <p:cNvPr id="2" name="Title 1"/>
-          <p:cNvSpPr>
-            <a:spLocks noGrp="1"/>
-          </p:cNvSpPr>
-          <p:nvPr>
-            <p:ph type="title"/>
-          </p:nvPr>
-        </p:nvSpPr>
-        <p:spPr/>
-        <p:txBody>
-          <a:bodyPr/>
-          <a:lstStyle/>
-          <a:p>
-            <a:r>
-              <a:t>Stage 1: Interview Students</a:t>
-            </a:r>
-          </a:p>
-        </p:txBody>
-      </p:sp>
-      <p:sp>
-        <p:nvSpPr>
-          <p:cNvPr id="3" name="Text Placeholder 2"/>
-          <p:cNvSpPr>
-            <a:spLocks noGrp="1"/>
-          </p:cNvSpPr>
-          <p:nvPr>
-            <p:ph type="body" idx="11" sz="quarter"/>
-          </p:nvPr>
-        </p:nvSpPr>
-        <p:spPr/>
-        <p:txBody>
-          <a:bodyPr/>
-          <a:lstStyle/>
-          <a:p/>
-          <a:p>
-            <a:pPr/>
-            <a:r>
-              <a:t>When do you have free time?</a:t>
-            </a:r>
-          </a:p>
-          <a:p>
-            <a:pPr/>
-            <a:r>
-              <a:t>What do you like doing with your family in your free time?</a:t>
-            </a:r>
-          </a:p>
-          <a:p>
-            <a:pPr/>
-            <a:r>
-              <a:t>What do you like doing with your friends in your free time?</a:t>
-            </a:r>
-          </a:p>
-          <a:p>
-            <a:pPr/>
-            <a:r>
-              <a:t>What leisure activities do you like doing on your own?</a:t>
-            </a:r>
-          </a:p>
-          <a:p>
-            <a:pPr/>
-            <a:r>
-              <a:t>What leisure activities would you like to try in the future?</a:t>
-            </a:r>
-          </a:p>
-        </p:txBody>
-      </p:sp>
-    </p:spTree>
-  </p:cSld>
-  <p:clrMapOvr>
-    <a:masterClrMapping/>
-  </p:clrMapOvr>
-</p:sld>
-</file>
-
-<file path=ppt/slides/slide69.xml><?xml version="1.0" encoding="utf-8"?>
-<p:sld xmlns:a="http://schemas.openxmlformats.org/drawingml/2006/main" xmlns:p="http://schemas.openxmlformats.org/presentationml/2006/main" xmlns:r="http://schemas.openxmlformats.org/officeDocument/2006/relationships">
-  <p:cSld>
-    <p:spTree>
-      <p:nvGrpSpPr>
-        <p:cNvPr id="1" name=""/>
-        <p:cNvGrpSpPr/>
-        <p:nvPr/>
-      </p:nvGrpSpPr>
-      <p:grpSpPr/>
-      <p:sp>
-        <p:nvSpPr>
-          <p:cNvPr id="2" name="Title 1"/>
-          <p:cNvSpPr>
-            <a:spLocks noGrp="1"/>
-          </p:cNvSpPr>
-          <p:nvPr>
-            <p:ph type="title"/>
-          </p:nvPr>
-        </p:nvSpPr>
-        <p:spPr/>
-        <p:txBody>
-          <a:bodyPr/>
-          <a:lstStyle/>
-          <a:p>
-            <a:r>
-              <a:t>Stage 2: Collect Answers</a:t>
-            </a:r>
-          </a:p>
-        </p:txBody>
-      </p:sp>
-      <p:sp>
-        <p:nvSpPr>
-          <p:cNvPr id="3" name="Text Placeholder 2"/>
-          <p:cNvSpPr>
-            <a:spLocks noGrp="1"/>
-          </p:cNvSpPr>
-          <p:nvPr>
-            <p:ph type="body" idx="11" sz="quarter"/>
-          </p:nvPr>
-        </p:nvSpPr>
-        <p:spPr/>
-        <p:txBody>
-          <a:bodyPr/>
-          <a:lstStyle/>
-          <a:p/>
-          <a:p>
-            <a:pPr/>
-            <a:r>
-              <a:t>Use the provided table to record the responses from your interviews.</a:t>
+              <a:t>Fill in the table with the collected data, ensuring each student's responses are recorded under the appropriate questions.</a:t>
             </a:r>
           </a:p>
         </p:txBody>
@@ -8638,6 +8313,172 @@
           </a:prstGeom>
         </p:spPr>
       </p:pic>
+    </p:spTree>
+  </p:cSld>
+  <p:clrMapOvr>
+    <a:masterClrMapping/>
+  </p:clrMapOvr>
+</p:sld>
+</file>
+
+<file path=ppt/slides/slide66.xml><?xml version="1.0" encoding="utf-8"?>
+<p:sld xmlns:a="http://schemas.openxmlformats.org/drawingml/2006/main" xmlns:p="http://schemas.openxmlformats.org/presentationml/2006/main" xmlns:r="http://schemas.openxmlformats.org/officeDocument/2006/relationships">
+  <p:cSld>
+    <p:spTree>
+      <p:nvGrpSpPr>
+        <p:cNvPr id="1" name=""/>
+        <p:cNvGrpSpPr/>
+        <p:nvPr/>
+      </p:nvGrpSpPr>
+      <p:grpSpPr/>
+      <p:sp>
+        <p:nvSpPr>
+          <p:cNvPr id="2" name="Title 1"/>
+          <p:cNvSpPr>
+            <a:spLocks noGrp="1"/>
+          </p:cNvSpPr>
+          <p:nvPr>
+            <p:ph type="title"/>
+          </p:nvPr>
+        </p:nvSpPr>
+        <p:spPr/>
+        <p:txBody>
+          <a:bodyPr/>
+          <a:lstStyle/>
+          <a:p>
+            <a:r>
+              <a:t>Stage 3: Report Findings</a:t>
+            </a:r>
+          </a:p>
+        </p:txBody>
+      </p:sp>
+      <p:sp>
+        <p:nvSpPr>
+          <p:cNvPr id="3" name="Text Placeholder 2"/>
+          <p:cNvSpPr>
+            <a:spLocks noGrp="1"/>
+          </p:cNvSpPr>
+          <p:nvPr>
+            <p:ph type="body" idx="11" sz="quarter"/>
+          </p:nvPr>
+        </p:nvSpPr>
+        <p:spPr/>
+        <p:txBody>
+          <a:bodyPr/>
+          <a:lstStyle/>
+          <a:p/>
+          <a:p>
+            <a:pPr/>
+            <a:r>
+              <a:t>Prepare and deliver a presentation based on the survey findings, using the guiding questions to structure your report.</a:t>
+            </a:r>
+          </a:p>
+          <a:p>
+            <a:pPr/>
+            <a:r>
+              <a:t>Guiding questions:</a:t>
+            </a:r>
+          </a:p>
+          <a:p>
+            <a:pPr/>
+            <a:r>
+              <a:t>1. How many students did you interview?</a:t>
+            </a:r>
+          </a:p>
+          <a:p>
+            <a:pPr/>
+            <a:r>
+              <a:t>2. When do the students have free time?</a:t>
+            </a:r>
+          </a:p>
+          <a:p>
+            <a:pPr/>
+            <a:r>
+              <a:t>3. What are the most popular activities they do with their family?</a:t>
+            </a:r>
+          </a:p>
+          <a:p>
+            <a:pPr/>
+            <a:r>
+              <a:t>4. What are the most popular activities they do with their friends?</a:t>
+            </a:r>
+          </a:p>
+          <a:p>
+            <a:pPr/>
+            <a:r>
+              <a:t>5. What are the most popular activities they do on their own?</a:t>
+            </a:r>
+          </a:p>
+          <a:p>
+            <a:pPr/>
+            <a:r>
+              <a:t>6. What leisure activities would they like to try in the future?</a:t>
+            </a:r>
+          </a:p>
+        </p:txBody>
+      </p:sp>
+    </p:spTree>
+  </p:cSld>
+  <p:clrMapOvr>
+    <a:masterClrMapping/>
+  </p:clrMapOvr>
+</p:sld>
+</file>
+
+<file path=ppt/slides/slide67.xml><?xml version="1.0" encoding="utf-8"?>
+<p:sld xmlns:a="http://schemas.openxmlformats.org/drawingml/2006/main" xmlns:p="http://schemas.openxmlformats.org/presentationml/2006/main" xmlns:r="http://schemas.openxmlformats.org/officeDocument/2006/relationships">
+  <p:cSld>
+    <p:spTree>
+      <p:nvGrpSpPr>
+        <p:cNvPr id="1" name=""/>
+        <p:cNvGrpSpPr/>
+        <p:nvPr/>
+      </p:nvGrpSpPr>
+      <p:grpSpPr/>
+      <p:sp>
+        <p:nvSpPr>
+          <p:cNvPr id="2" name="Title 1"/>
+          <p:cNvSpPr>
+            <a:spLocks noGrp="1"/>
+          </p:cNvSpPr>
+          <p:nvPr>
+            <p:ph type="title"/>
+          </p:nvPr>
+        </p:nvSpPr>
+        <p:spPr/>
+        <p:txBody>
+          <a:bodyPr/>
+          <a:lstStyle/>
+          <a:p>
+            <a:r>
+              <a:t>Wrap-up</a:t>
+            </a:r>
+          </a:p>
+        </p:txBody>
+      </p:sp>
+      <p:sp>
+        <p:nvSpPr>
+          <p:cNvPr id="3" name="Text Placeholder 2"/>
+          <p:cNvSpPr>
+            <a:spLocks noGrp="1"/>
+          </p:cNvSpPr>
+          <p:nvPr>
+            <p:ph type="body" idx="11" sz="quarter"/>
+          </p:nvPr>
+        </p:nvSpPr>
+        <p:spPr/>
+        <p:txBody>
+          <a:bodyPr/>
+          <a:lstStyle/>
+          <a:p/>
+          <a:p>
+            <a:pPr/>
+            <a:r>
+              <a:t>Participate in the pronunciation practice and ask any remaining questions about the lesson.</a:t>
+            </a:r>
+          </a:p>
+        </p:txBody>
+      </p:sp>
     </p:spTree>
   </p:cSld>
   <p:clrMapOvr>
@@ -9116,240 +8957,6 @@
         <p14:creationId xmlns:p14="http://schemas.microsoft.com/office/powerpoint/2010/main" val="112335351"/>
       </p:ext>
     </p:extLst>
-  </p:cSld>
-  <p:clrMapOvr>
-    <a:masterClrMapping/>
-  </p:clrMapOvr>
-</p:sld>
-</file>
-
-<file path=ppt/slides/slide70.xml><?xml version="1.0" encoding="utf-8"?>
-<p:sld xmlns:a="http://schemas.openxmlformats.org/drawingml/2006/main" xmlns:p="http://schemas.openxmlformats.org/presentationml/2006/main" xmlns:r="http://schemas.openxmlformats.org/officeDocument/2006/relationships">
-  <p:cSld>
-    <p:spTree>
-      <p:nvGrpSpPr>
-        <p:cNvPr id="1" name=""/>
-        <p:cNvGrpSpPr/>
-        <p:nvPr/>
-      </p:nvGrpSpPr>
-      <p:grpSpPr/>
-      <p:sp>
-        <p:nvSpPr>
-          <p:cNvPr id="2" name="Title 1"/>
-          <p:cNvSpPr>
-            <a:spLocks noGrp="1"/>
-          </p:cNvSpPr>
-          <p:nvPr>
-            <p:ph type="title"/>
-          </p:nvPr>
-        </p:nvSpPr>
-        <p:spPr/>
-        <p:txBody>
-          <a:bodyPr/>
-          <a:lstStyle/>
-          <a:p>
-            <a:r>
-              <a:t>Stage 3: Report Findings</a:t>
-            </a:r>
-          </a:p>
-        </p:txBody>
-      </p:sp>
-      <p:sp>
-        <p:nvSpPr>
-          <p:cNvPr id="3" name="Text Placeholder 2"/>
-          <p:cNvSpPr>
-            <a:spLocks noGrp="1"/>
-          </p:cNvSpPr>
-          <p:nvPr>
-            <p:ph type="body" idx="11" sz="quarter"/>
-          </p:nvPr>
-        </p:nvSpPr>
-        <p:spPr/>
-        <p:txBody>
-          <a:bodyPr/>
-          <a:lstStyle/>
-          <a:p/>
-          <a:p>
-            <a:pPr/>
-            <a:r>
-              <a:t>How many students did you interview?</a:t>
-            </a:r>
-          </a:p>
-          <a:p>
-            <a:pPr/>
-            <a:r>
-              <a:t>When do the students have free time?</a:t>
-            </a:r>
-          </a:p>
-          <a:p>
-            <a:pPr/>
-            <a:r>
-              <a:t>What are the most popular activities they do with their family?</a:t>
-            </a:r>
-          </a:p>
-          <a:p>
-            <a:pPr/>
-            <a:r>
-              <a:t>What are the most popular activities they do with their friends?</a:t>
-            </a:r>
-          </a:p>
-          <a:p>
-            <a:pPr/>
-            <a:r>
-              <a:t>What are the most popular activities they do on their own?</a:t>
-            </a:r>
-          </a:p>
-          <a:p>
-            <a:pPr/>
-            <a:r>
-              <a:t>What leisure activities would they like to try in the future?</a:t>
-            </a:r>
-          </a:p>
-        </p:txBody>
-      </p:sp>
-    </p:spTree>
-  </p:cSld>
-  <p:clrMapOvr>
-    <a:masterClrMapping/>
-  </p:clrMapOvr>
-</p:sld>
-</file>
-
-<file path=ppt/slides/slide71.xml><?xml version="1.0" encoding="utf-8"?>
-<p:sld xmlns:a="http://schemas.openxmlformats.org/drawingml/2006/main" xmlns:p="http://schemas.openxmlformats.org/presentationml/2006/main" xmlns:r="http://schemas.openxmlformats.org/officeDocument/2006/relationships">
-  <p:cSld>
-    <p:spTree>
-      <p:nvGrpSpPr>
-        <p:cNvPr id="1" name=""/>
-        <p:cNvGrpSpPr/>
-        <p:nvPr/>
-      </p:nvGrpSpPr>
-      <p:grpSpPr/>
-      <p:sp>
-        <p:nvSpPr>
-          <p:cNvPr id="2" name="Title 1"/>
-          <p:cNvSpPr>
-            <a:spLocks noGrp="1"/>
-          </p:cNvSpPr>
-          <p:nvPr>
-            <p:ph type="title"/>
-          </p:nvPr>
-        </p:nvSpPr>
-        <p:spPr/>
-        <p:txBody>
-          <a:bodyPr/>
-          <a:lstStyle/>
-          <a:p>
-            <a:r>
-              <a:t>Stage 4: Use Language Skills</a:t>
-            </a:r>
-          </a:p>
-        </p:txBody>
-      </p:sp>
-      <p:sp>
-        <p:nvSpPr>
-          <p:cNvPr id="3" name="Text Placeholder 2"/>
-          <p:cNvSpPr>
-            <a:spLocks noGrp="1"/>
-          </p:cNvSpPr>
-          <p:nvPr>
-            <p:ph type="body" idx="11" sz="quarter"/>
-          </p:nvPr>
-        </p:nvSpPr>
-        <p:spPr/>
-        <p:txBody>
-          <a:bodyPr/>
-          <a:lstStyle/>
-          <a:p/>
-          <a:p>
-            <a:pPr/>
-            <a:r>
-              <a:t>Use words related to leisure activities.</a:t>
-            </a:r>
-          </a:p>
-          <a:p>
-            <a:pPr/>
-            <a:r>
-              <a:t>Pronounce /uː/ and /ʊ/ correctly.</a:t>
-            </a:r>
-          </a:p>
-          <a:p>
-            <a:pPr/>
-            <a:r>
-              <a:t>Use verbs of liking/disliking with gerunds/to-infinitives.</a:t>
-            </a:r>
-          </a:p>
-          <a:p>
-            <a:pPr/>
-            <a:r>
-              <a:t>Invite and accept invitations.</a:t>
-            </a:r>
-          </a:p>
-        </p:txBody>
-      </p:sp>
-    </p:spTree>
-  </p:cSld>
-  <p:clrMapOvr>
-    <a:masterClrMapping/>
-  </p:clrMapOvr>
-</p:sld>
-</file>
-
-<file path=ppt/slides/slide72.xml><?xml version="1.0" encoding="utf-8"?>
-<p:sld xmlns:a="http://schemas.openxmlformats.org/drawingml/2006/main" xmlns:p="http://schemas.openxmlformats.org/presentationml/2006/main" xmlns:r="http://schemas.openxmlformats.org/officeDocument/2006/relationships">
-  <p:cSld>
-    <p:spTree>
-      <p:nvGrpSpPr>
-        <p:cNvPr id="1" name=""/>
-        <p:cNvGrpSpPr/>
-        <p:nvPr/>
-      </p:nvGrpSpPr>
-      <p:grpSpPr/>
-      <p:sp>
-        <p:nvSpPr>
-          <p:cNvPr id="2" name="Title 1"/>
-          <p:cNvSpPr>
-            <a:spLocks noGrp="1"/>
-          </p:cNvSpPr>
-          <p:nvPr>
-            <p:ph type="title"/>
-          </p:nvPr>
-        </p:nvSpPr>
-        <p:spPr/>
-        <p:txBody>
-          <a:bodyPr/>
-          <a:lstStyle/>
-          <a:p>
-            <a:r>
-              <a:t>Wrap-up</a:t>
-            </a:r>
-          </a:p>
-        </p:txBody>
-      </p:sp>
-      <p:sp>
-        <p:nvSpPr>
-          <p:cNvPr id="3" name="Text Placeholder 2"/>
-          <p:cNvSpPr>
-            <a:spLocks noGrp="1"/>
-          </p:cNvSpPr>
-          <p:nvPr>
-            <p:ph type="body" idx="11" sz="quarter"/>
-          </p:nvPr>
-        </p:nvSpPr>
-        <p:spPr/>
-        <p:txBody>
-          <a:bodyPr/>
-          <a:lstStyle/>
-          <a:p/>
-          <a:p>
-            <a:pPr/>
-            <a:r>
-              <a:t>Summarize the project and address any questions.</a:t>
-            </a:r>
-          </a:p>
-        </p:txBody>
-      </p:sp>
-    </p:spTree>
   </p:cSld>
   <p:clrMapOvr>
     <a:masterClrMapping/>

</xml_diff>